<commit_message>
docs(cost-breakdowns): panel-styled cost slides + ELI8 explainer
- cheap_model_cost_slides.py: add _rrect / _panel helpers (rounded-rect
  panels with the default autoshape shadow suppressed) and restyle the slides.
- regenerate cheap_model_cost_slides.pptx.
- add EXPLAINER_eli8.md: plain-language walkthrough of the 3 cost slides
  (the test, its cost, the puzzle domains, what's cuttable, and the smallest
  still-real version of the experiment).
</commit_message>
<xml_diff>
--- a/development/cost-breakdowns/cheap_model_cost_slides.pptx
+++ b/development/cost-breakdowns/cheap_model_cost_slides.pptx
@@ -5,11 +5,12 @@
     <p:sldMasterId id="2147483648" r:id="rId1"/>
   </p:sldMasterIdLst>
   <p:sldIdLst>
-    <p:sldId id="256" r:id="rId2"/>
-    <p:sldId id="257" r:id="rId3"/>
-    <p:sldId id="258" r:id="rId4"/>
+    <p:sldId id="256" r:id="rId7"/>
+    <p:sldId id="257" r:id="rId8"/>
+    <p:sldId id="258" r:id="rId9"/>
+    <p:sldId id="259" r:id="rId10"/>
   </p:sldIdLst>
-  <p:sldSz cx="12192000" cy="6858000"/>
+  <p:sldSz cx="12191695" cy="6858000" type="screen4x3"/>
   <p:notesSz cx="6858000" cy="9144000"/>
   <p:defaultTextStyle>
     <a:defPPr>
@@ -106,22 +107,6 @@
       </a:defRPr>
     </a:lvl9pPr>
   </p:defaultTextStyle>
-  <p:extLst>
-    <p:ext uri="{EFAFB233-063F-42B5-8137-9DF3F51BA10A}">
-      <p15:sldGuideLst xmlns:p15="http://schemas.microsoft.com/office/powerpoint/2012/main">
-        <p15:guide id="1" orient="horz" pos="2160">
-          <p15:clr>
-            <a:srgbClr val="A4A3A4"/>
-          </p15:clr>
-        </p15:guide>
-        <p15:guide id="2" pos="2880">
-          <p15:clr>
-            <a:srgbClr val="A4A3A4"/>
-          </p15:clr>
-        </p15:guide>
-      </p15:sldGuideLst>
-    </p:ext>
-  </p:extLst>
 </p:presentation>
 </file>
 
@@ -163,9 +148,10 @@
           <a:lstStyle/>
           <a:p>
             <a:r>
-              <a:rPr lang="en-US"/>
+              <a:rPr lang="en-US" smtClean="0"/>
               <a:t>Click to edit Master title style</a:t>
             </a:r>
+            <a:endParaRPr lang="en-US"/>
           </a:p>
         </p:txBody>
       </p:sp>
@@ -281,9 +267,10 @@
           </a:lstStyle>
           <a:p>
             <a:r>
-              <a:rPr lang="en-US"/>
+              <a:rPr lang="en-US" smtClean="0"/>
               <a:t>Click to edit Master subtitle style</a:t>
             </a:r>
+            <a:endParaRPr lang="en-US"/>
           </a:p>
         </p:txBody>
       </p:sp>
@@ -304,7 +291,7 @@
           <a:p>
             <a:fld id="{5BCAD085-E8A6-8845-BD4E-CB4CCA059FC4}" type="datetimeFigureOut">
               <a:rPr lang="en-US" smtClean="0"/>
-              <a:t>6/15/26</a:t>
+              <a:t>1/27/13</a:t>
             </a:fld>
             <a:endParaRPr lang="en-US"/>
           </a:p>
@@ -398,9 +385,10 @@
           <a:lstStyle/>
           <a:p>
             <a:r>
-              <a:rPr lang="en-US"/>
+              <a:rPr lang="en-US" smtClean="0"/>
               <a:t>Click to edit Master title style</a:t>
             </a:r>
+            <a:endParaRPr lang="en-US"/>
           </a:p>
         </p:txBody>
       </p:sp>
@@ -421,37 +409,38 @@
           <a:p>
             <a:pPr lvl="0"/>
             <a:r>
-              <a:rPr lang="en-US"/>
+              <a:rPr lang="en-US" smtClean="0"/>
               <a:t>Click to edit Master text styles</a:t>
             </a:r>
           </a:p>
           <a:p>
             <a:pPr lvl="1"/>
             <a:r>
-              <a:rPr lang="en-US"/>
+              <a:rPr lang="en-US" smtClean="0"/>
               <a:t>Second level</a:t>
             </a:r>
           </a:p>
           <a:p>
             <a:pPr lvl="2"/>
             <a:r>
-              <a:rPr lang="en-US"/>
+              <a:rPr lang="en-US" smtClean="0"/>
               <a:t>Third level</a:t>
             </a:r>
           </a:p>
           <a:p>
             <a:pPr lvl="3"/>
             <a:r>
-              <a:rPr lang="en-US"/>
+              <a:rPr lang="en-US" smtClean="0"/>
               <a:t>Fourth level</a:t>
             </a:r>
           </a:p>
           <a:p>
             <a:pPr lvl="4"/>
             <a:r>
-              <a:rPr lang="en-US"/>
+              <a:rPr lang="en-US" smtClean="0"/>
               <a:t>Fifth level</a:t>
             </a:r>
+            <a:endParaRPr lang="en-US"/>
           </a:p>
         </p:txBody>
       </p:sp>
@@ -472,7 +461,7 @@
           <a:p>
             <a:fld id="{5BCAD085-E8A6-8845-BD4E-CB4CCA059FC4}" type="datetimeFigureOut">
               <a:rPr lang="en-US" smtClean="0"/>
-              <a:t>6/15/26</a:t>
+              <a:t>1/27/13</a:t>
             </a:fld>
             <a:endParaRPr lang="en-US"/>
           </a:p>
@@ -571,9 +560,10 @@
           <a:lstStyle/>
           <a:p>
             <a:r>
-              <a:rPr lang="en-US"/>
+              <a:rPr lang="en-US" smtClean="0"/>
               <a:t>Click to edit Master title style</a:t>
             </a:r>
+            <a:endParaRPr lang="en-US"/>
           </a:p>
         </p:txBody>
       </p:sp>
@@ -599,37 +589,38 @@
           <a:p>
             <a:pPr lvl="0"/>
             <a:r>
-              <a:rPr lang="en-US"/>
+              <a:rPr lang="en-US" smtClean="0"/>
               <a:t>Click to edit Master text styles</a:t>
             </a:r>
           </a:p>
           <a:p>
             <a:pPr lvl="1"/>
             <a:r>
-              <a:rPr lang="en-US"/>
+              <a:rPr lang="en-US" smtClean="0"/>
               <a:t>Second level</a:t>
             </a:r>
           </a:p>
           <a:p>
             <a:pPr lvl="2"/>
             <a:r>
-              <a:rPr lang="en-US"/>
+              <a:rPr lang="en-US" smtClean="0"/>
               <a:t>Third level</a:t>
             </a:r>
           </a:p>
           <a:p>
             <a:pPr lvl="3"/>
             <a:r>
-              <a:rPr lang="en-US"/>
+              <a:rPr lang="en-US" smtClean="0"/>
               <a:t>Fourth level</a:t>
             </a:r>
           </a:p>
           <a:p>
             <a:pPr lvl="4"/>
             <a:r>
-              <a:rPr lang="en-US"/>
+              <a:rPr lang="en-US" smtClean="0"/>
               <a:t>Fifth level</a:t>
             </a:r>
+            <a:endParaRPr lang="en-US"/>
           </a:p>
         </p:txBody>
       </p:sp>
@@ -650,7 +641,7 @@
           <a:p>
             <a:fld id="{5BCAD085-E8A6-8845-BD4E-CB4CCA059FC4}" type="datetimeFigureOut">
               <a:rPr lang="en-US" smtClean="0"/>
-              <a:t>6/15/26</a:t>
+              <a:t>1/27/13</a:t>
             </a:fld>
             <a:endParaRPr lang="en-US"/>
           </a:p>
@@ -744,9 +735,10 @@
           <a:lstStyle/>
           <a:p>
             <a:r>
-              <a:rPr lang="en-US"/>
+              <a:rPr lang="en-US" smtClean="0"/>
               <a:t>Click to edit Master title style</a:t>
             </a:r>
+            <a:endParaRPr lang="en-US"/>
           </a:p>
         </p:txBody>
       </p:sp>
@@ -767,37 +759,38 @@
           <a:p>
             <a:pPr lvl="0"/>
             <a:r>
-              <a:rPr lang="en-US"/>
+              <a:rPr lang="en-US" smtClean="0"/>
               <a:t>Click to edit Master text styles</a:t>
             </a:r>
           </a:p>
           <a:p>
             <a:pPr lvl="1"/>
             <a:r>
-              <a:rPr lang="en-US"/>
+              <a:rPr lang="en-US" smtClean="0"/>
               <a:t>Second level</a:t>
             </a:r>
           </a:p>
           <a:p>
             <a:pPr lvl="2"/>
             <a:r>
-              <a:rPr lang="en-US"/>
+              <a:rPr lang="en-US" smtClean="0"/>
               <a:t>Third level</a:t>
             </a:r>
           </a:p>
           <a:p>
             <a:pPr lvl="3"/>
             <a:r>
-              <a:rPr lang="en-US"/>
+              <a:rPr lang="en-US" smtClean="0"/>
               <a:t>Fourth level</a:t>
             </a:r>
           </a:p>
           <a:p>
             <a:pPr lvl="4"/>
             <a:r>
-              <a:rPr lang="en-US"/>
+              <a:rPr lang="en-US" smtClean="0"/>
               <a:t>Fifth level</a:t>
             </a:r>
+            <a:endParaRPr lang="en-US"/>
           </a:p>
         </p:txBody>
       </p:sp>
@@ -818,7 +811,7 @@
           <a:p>
             <a:fld id="{5BCAD085-E8A6-8845-BD4E-CB4CCA059FC4}" type="datetimeFigureOut">
               <a:rPr lang="en-US" smtClean="0"/>
-              <a:t>6/15/26</a:t>
+              <a:t>1/27/13</a:t>
             </a:fld>
             <a:endParaRPr lang="en-US"/>
           </a:p>
@@ -921,9 +914,10 @@
           </a:lstStyle>
           <a:p>
             <a:r>
-              <a:rPr lang="en-US"/>
+              <a:rPr lang="en-US" smtClean="0"/>
               <a:t>Click to edit Master title style</a:t>
             </a:r>
+            <a:endParaRPr lang="en-US"/>
           </a:p>
         </p:txBody>
       </p:sp>
@@ -1040,7 +1034,7 @@
           <a:p>
             <a:pPr lvl="0"/>
             <a:r>
-              <a:rPr lang="en-US"/>
+              <a:rPr lang="en-US" smtClean="0"/>
               <a:t>Click to edit Master text styles</a:t>
             </a:r>
           </a:p>
@@ -1063,7 +1057,7 @@
           <a:p>
             <a:fld id="{5BCAD085-E8A6-8845-BD4E-CB4CCA059FC4}" type="datetimeFigureOut">
               <a:rPr lang="en-US" smtClean="0"/>
-              <a:t>6/15/26</a:t>
+              <a:t>1/27/13</a:t>
             </a:fld>
             <a:endParaRPr lang="en-US"/>
           </a:p>
@@ -1157,9 +1151,10 @@
           <a:lstStyle/>
           <a:p>
             <a:r>
-              <a:rPr lang="en-US"/>
+              <a:rPr lang="en-US" smtClean="0"/>
               <a:t>Click to edit Master title style</a:t>
             </a:r>
+            <a:endParaRPr lang="en-US"/>
           </a:p>
         </p:txBody>
       </p:sp>
@@ -1213,37 +1208,38 @@
           <a:p>
             <a:pPr lvl="0"/>
             <a:r>
-              <a:rPr lang="en-US"/>
+              <a:rPr lang="en-US" smtClean="0"/>
               <a:t>Click to edit Master text styles</a:t>
             </a:r>
           </a:p>
           <a:p>
             <a:pPr lvl="1"/>
             <a:r>
-              <a:rPr lang="en-US"/>
+              <a:rPr lang="en-US" smtClean="0"/>
               <a:t>Second level</a:t>
             </a:r>
           </a:p>
           <a:p>
             <a:pPr lvl="2"/>
             <a:r>
-              <a:rPr lang="en-US"/>
+              <a:rPr lang="en-US" smtClean="0"/>
               <a:t>Third level</a:t>
             </a:r>
           </a:p>
           <a:p>
             <a:pPr lvl="3"/>
             <a:r>
-              <a:rPr lang="en-US"/>
+              <a:rPr lang="en-US" smtClean="0"/>
               <a:t>Fourth level</a:t>
             </a:r>
           </a:p>
           <a:p>
             <a:pPr lvl="4"/>
             <a:r>
-              <a:rPr lang="en-US"/>
+              <a:rPr lang="en-US" smtClean="0"/>
               <a:t>Fifth level</a:t>
             </a:r>
+            <a:endParaRPr lang="en-US"/>
           </a:p>
         </p:txBody>
       </p:sp>
@@ -1297,37 +1293,38 @@
           <a:p>
             <a:pPr lvl="0"/>
             <a:r>
-              <a:rPr lang="en-US"/>
+              <a:rPr lang="en-US" smtClean="0"/>
               <a:t>Click to edit Master text styles</a:t>
             </a:r>
           </a:p>
           <a:p>
             <a:pPr lvl="1"/>
             <a:r>
-              <a:rPr lang="en-US"/>
+              <a:rPr lang="en-US" smtClean="0"/>
               <a:t>Second level</a:t>
             </a:r>
           </a:p>
           <a:p>
             <a:pPr lvl="2"/>
             <a:r>
-              <a:rPr lang="en-US"/>
+              <a:rPr lang="en-US" smtClean="0"/>
               <a:t>Third level</a:t>
             </a:r>
           </a:p>
           <a:p>
             <a:pPr lvl="3"/>
             <a:r>
-              <a:rPr lang="en-US"/>
+              <a:rPr lang="en-US" smtClean="0"/>
               <a:t>Fourth level</a:t>
             </a:r>
           </a:p>
           <a:p>
             <a:pPr lvl="4"/>
             <a:r>
-              <a:rPr lang="en-US"/>
+              <a:rPr lang="en-US" smtClean="0"/>
               <a:t>Fifth level</a:t>
             </a:r>
+            <a:endParaRPr lang="en-US"/>
           </a:p>
         </p:txBody>
       </p:sp>
@@ -1348,7 +1345,7 @@
           <a:p>
             <a:fld id="{5BCAD085-E8A6-8845-BD4E-CB4CCA059FC4}" type="datetimeFigureOut">
               <a:rPr lang="en-US" smtClean="0"/>
-              <a:t>6/15/26</a:t>
+              <a:t>1/27/13</a:t>
             </a:fld>
             <a:endParaRPr lang="en-US"/>
           </a:p>
@@ -1446,9 +1443,10 @@
           </a:lstStyle>
           <a:p>
             <a:r>
-              <a:rPr lang="en-US"/>
+              <a:rPr lang="en-US" smtClean="0"/>
               <a:t>Click to edit Master title style</a:t>
             </a:r>
+            <a:endParaRPr lang="en-US"/>
           </a:p>
         </p:txBody>
       </p:sp>
@@ -1511,7 +1509,7 @@
           <a:p>
             <a:pPr lvl="0"/>
             <a:r>
-              <a:rPr lang="en-US"/>
+              <a:rPr lang="en-US" smtClean="0"/>
               <a:t>Click to edit Master text styles</a:t>
             </a:r>
           </a:p>
@@ -1567,37 +1565,38 @@
           <a:p>
             <a:pPr lvl="0"/>
             <a:r>
-              <a:rPr lang="en-US"/>
+              <a:rPr lang="en-US" smtClean="0"/>
               <a:t>Click to edit Master text styles</a:t>
             </a:r>
           </a:p>
           <a:p>
             <a:pPr lvl="1"/>
             <a:r>
-              <a:rPr lang="en-US"/>
+              <a:rPr lang="en-US" smtClean="0"/>
               <a:t>Second level</a:t>
             </a:r>
           </a:p>
           <a:p>
             <a:pPr lvl="2"/>
             <a:r>
-              <a:rPr lang="en-US"/>
+              <a:rPr lang="en-US" smtClean="0"/>
               <a:t>Third level</a:t>
             </a:r>
           </a:p>
           <a:p>
             <a:pPr lvl="3"/>
             <a:r>
-              <a:rPr lang="en-US"/>
+              <a:rPr lang="en-US" smtClean="0"/>
               <a:t>Fourth level</a:t>
             </a:r>
           </a:p>
           <a:p>
             <a:pPr lvl="4"/>
             <a:r>
-              <a:rPr lang="en-US"/>
+              <a:rPr lang="en-US" smtClean="0"/>
               <a:t>Fifth level</a:t>
             </a:r>
+            <a:endParaRPr lang="en-US"/>
           </a:p>
         </p:txBody>
       </p:sp>
@@ -1660,7 +1659,7 @@
           <a:p>
             <a:pPr lvl="0"/>
             <a:r>
-              <a:rPr lang="en-US"/>
+              <a:rPr lang="en-US" smtClean="0"/>
               <a:t>Click to edit Master text styles</a:t>
             </a:r>
           </a:p>
@@ -1716,37 +1715,38 @@
           <a:p>
             <a:pPr lvl="0"/>
             <a:r>
-              <a:rPr lang="en-US"/>
+              <a:rPr lang="en-US" smtClean="0"/>
               <a:t>Click to edit Master text styles</a:t>
             </a:r>
           </a:p>
           <a:p>
             <a:pPr lvl="1"/>
             <a:r>
-              <a:rPr lang="en-US"/>
+              <a:rPr lang="en-US" smtClean="0"/>
               <a:t>Second level</a:t>
             </a:r>
           </a:p>
           <a:p>
             <a:pPr lvl="2"/>
             <a:r>
-              <a:rPr lang="en-US"/>
+              <a:rPr lang="en-US" smtClean="0"/>
               <a:t>Third level</a:t>
             </a:r>
           </a:p>
           <a:p>
             <a:pPr lvl="3"/>
             <a:r>
-              <a:rPr lang="en-US"/>
+              <a:rPr lang="en-US" smtClean="0"/>
               <a:t>Fourth level</a:t>
             </a:r>
           </a:p>
           <a:p>
             <a:pPr lvl="4"/>
             <a:r>
-              <a:rPr lang="en-US"/>
+              <a:rPr lang="en-US" smtClean="0"/>
               <a:t>Fifth level</a:t>
             </a:r>
+            <a:endParaRPr lang="en-US"/>
           </a:p>
         </p:txBody>
       </p:sp>
@@ -1767,7 +1767,7 @@
           <a:p>
             <a:fld id="{5BCAD085-E8A6-8845-BD4E-CB4CCA059FC4}" type="datetimeFigureOut">
               <a:rPr lang="en-US" smtClean="0"/>
-              <a:t>6/15/26</a:t>
+              <a:t>1/27/13</a:t>
             </a:fld>
             <a:endParaRPr lang="en-US"/>
           </a:p>
@@ -1861,9 +1861,10 @@
           <a:lstStyle/>
           <a:p>
             <a:r>
-              <a:rPr lang="en-US"/>
+              <a:rPr lang="en-US" smtClean="0"/>
               <a:t>Click to edit Master title style</a:t>
             </a:r>
+            <a:endParaRPr lang="en-US"/>
           </a:p>
         </p:txBody>
       </p:sp>
@@ -1884,7 +1885,7 @@
           <a:p>
             <a:fld id="{5BCAD085-E8A6-8845-BD4E-CB4CCA059FC4}" type="datetimeFigureOut">
               <a:rPr lang="en-US" smtClean="0"/>
-              <a:t>6/15/26</a:t>
+              <a:t>1/27/13</a:t>
             </a:fld>
             <a:endParaRPr lang="en-US"/>
           </a:p>
@@ -1979,7 +1980,7 @@
           <a:p>
             <a:fld id="{5BCAD085-E8A6-8845-BD4E-CB4CCA059FC4}" type="datetimeFigureOut">
               <a:rPr lang="en-US" smtClean="0"/>
-              <a:t>6/15/26</a:t>
+              <a:t>1/27/13</a:t>
             </a:fld>
             <a:endParaRPr lang="en-US"/>
           </a:p>
@@ -2082,9 +2083,10 @@
           </a:lstStyle>
           <a:p>
             <a:r>
-              <a:rPr lang="en-US"/>
+              <a:rPr lang="en-US" smtClean="0"/>
               <a:t>Click to edit Master title style</a:t>
             </a:r>
+            <a:endParaRPr lang="en-US"/>
           </a:p>
         </p:txBody>
       </p:sp>
@@ -2138,37 +2140,38 @@
           <a:p>
             <a:pPr lvl="0"/>
             <a:r>
-              <a:rPr lang="en-US"/>
+              <a:rPr lang="en-US" smtClean="0"/>
               <a:t>Click to edit Master text styles</a:t>
             </a:r>
           </a:p>
           <a:p>
             <a:pPr lvl="1"/>
             <a:r>
-              <a:rPr lang="en-US"/>
+              <a:rPr lang="en-US" smtClean="0"/>
               <a:t>Second level</a:t>
             </a:r>
           </a:p>
           <a:p>
             <a:pPr lvl="2"/>
             <a:r>
-              <a:rPr lang="en-US"/>
+              <a:rPr lang="en-US" smtClean="0"/>
               <a:t>Third level</a:t>
             </a:r>
           </a:p>
           <a:p>
             <a:pPr lvl="3"/>
             <a:r>
-              <a:rPr lang="en-US"/>
+              <a:rPr lang="en-US" smtClean="0"/>
               <a:t>Fourth level</a:t>
             </a:r>
           </a:p>
           <a:p>
             <a:pPr lvl="4"/>
             <a:r>
-              <a:rPr lang="en-US"/>
+              <a:rPr lang="en-US" smtClean="0"/>
               <a:t>Fifth level</a:t>
             </a:r>
+            <a:endParaRPr lang="en-US"/>
           </a:p>
         </p:txBody>
       </p:sp>
@@ -2231,7 +2234,7 @@
           <a:p>
             <a:pPr lvl="0"/>
             <a:r>
-              <a:rPr lang="en-US"/>
+              <a:rPr lang="en-US" smtClean="0"/>
               <a:t>Click to edit Master text styles</a:t>
             </a:r>
           </a:p>
@@ -2254,7 +2257,7 @@
           <a:p>
             <a:fld id="{5BCAD085-E8A6-8845-BD4E-CB4CCA059FC4}" type="datetimeFigureOut">
               <a:rPr lang="en-US" smtClean="0"/>
-              <a:t>6/15/26</a:t>
+              <a:t>1/27/13</a:t>
             </a:fld>
             <a:endParaRPr lang="en-US"/>
           </a:p>
@@ -2357,9 +2360,10 @@
           </a:lstStyle>
           <a:p>
             <a:r>
-              <a:rPr lang="en-US"/>
+              <a:rPr lang="en-US" smtClean="0"/>
               <a:t>Click to edit Master title style</a:t>
             </a:r>
+            <a:endParaRPr lang="en-US"/>
           </a:p>
         </p:txBody>
       </p:sp>
@@ -2483,7 +2487,7 @@
           <a:p>
             <a:pPr lvl="0"/>
             <a:r>
-              <a:rPr lang="en-US"/>
+              <a:rPr lang="en-US" smtClean="0"/>
               <a:t>Click to edit Master text styles</a:t>
             </a:r>
           </a:p>
@@ -2506,7 +2510,7 @@
           <a:p>
             <a:fld id="{5BCAD085-E8A6-8845-BD4E-CB4CCA059FC4}" type="datetimeFigureOut">
               <a:rPr lang="en-US" smtClean="0"/>
-              <a:t>6/15/26</a:t>
+              <a:t>1/27/13</a:t>
             </a:fld>
             <a:endParaRPr lang="en-US"/>
           </a:p>
@@ -2615,9 +2619,10 @@
           <a:lstStyle/>
           <a:p>
             <a:r>
-              <a:rPr lang="en-US"/>
+              <a:rPr lang="en-US" smtClean="0"/>
               <a:t>Click to edit Master title style</a:t>
             </a:r>
+            <a:endParaRPr lang="en-US"/>
           </a:p>
         </p:txBody>
       </p:sp>
@@ -2648,37 +2653,38 @@
           <a:p>
             <a:pPr lvl="0"/>
             <a:r>
-              <a:rPr lang="en-US"/>
+              <a:rPr lang="en-US" smtClean="0"/>
               <a:t>Click to edit Master text styles</a:t>
             </a:r>
           </a:p>
           <a:p>
             <a:pPr lvl="1"/>
             <a:r>
-              <a:rPr lang="en-US"/>
+              <a:rPr lang="en-US" smtClean="0"/>
               <a:t>Second level</a:t>
             </a:r>
           </a:p>
           <a:p>
             <a:pPr lvl="2"/>
             <a:r>
-              <a:rPr lang="en-US"/>
+              <a:rPr lang="en-US" smtClean="0"/>
               <a:t>Third level</a:t>
             </a:r>
           </a:p>
           <a:p>
             <a:pPr lvl="3"/>
             <a:r>
-              <a:rPr lang="en-US"/>
+              <a:rPr lang="en-US" smtClean="0"/>
               <a:t>Fourth level</a:t>
             </a:r>
           </a:p>
           <a:p>
             <a:pPr lvl="4"/>
             <a:r>
-              <a:rPr lang="en-US"/>
+              <a:rPr lang="en-US" smtClean="0"/>
               <a:t>Fifth level</a:t>
             </a:r>
+            <a:endParaRPr lang="en-US"/>
           </a:p>
         </p:txBody>
       </p:sp>
@@ -2717,7 +2723,7 @@
           <a:p>
             <a:fld id="{5BCAD085-E8A6-8845-BD4E-CB4CCA059FC4}" type="datetimeFigureOut">
               <a:rPr lang="en-US" smtClean="0"/>
-              <a:t>6/15/26</a:t>
+              <a:t>1/27/13</a:t>
             </a:fld>
             <a:endParaRPr lang="en-US"/>
           </a:p>
@@ -3076,7 +3082,7 @@
 </file>
 
 <file path=ppt/slides/slide1.xml><?xml version="1.0" encoding="utf-8"?>
-<p:sld xmlns:a="http://schemas.openxmlformats.org/drawingml/2006/main" xmlns:r="http://schemas.openxmlformats.org/officeDocument/2006/relationships" xmlns:p="http://schemas.openxmlformats.org/presentationml/2006/main">
+<p:sld xmlns:a="http://schemas.openxmlformats.org/drawingml/2006/main" xmlns:p="http://schemas.openxmlformats.org/presentationml/2006/main" xmlns:r="http://schemas.openxmlformats.org/officeDocument/2006/relationships">
   <p:cSld>
     <p:spTree>
       <p:nvGrpSpPr>
@@ -3084,14 +3090,7 @@
         <p:cNvGrpSpPr/>
         <p:nvPr/>
       </p:nvGrpSpPr>
-      <p:grpSpPr>
-        <a:xfrm>
-          <a:off x="0" y="0"/>
-          <a:ext cx="0" cy="0"/>
-          <a:chOff x="0" y="0"/>
-          <a:chExt cx="0" cy="0"/>
-        </a:xfrm>
-      </p:grpSpPr>
+      <p:grpSpPr/>
       <p:sp>
         <p:nvSpPr>
           <p:cNvPr id="2" name="TextBox 1"/>
@@ -3177,46 +3176,16 @@
                 <a:tableStyleId>{5C22544A-7EE6-4342-B048-85BDC9FD1C3A}</a:tableStyleId>
               </a:tblPr>
               <a:tblGrid>
-                <a:gridCol w="2148840">
-                  <a:extLst>
-                    <a:ext uri="{9D8B030D-6E8A-4147-A177-3AD203B41FA5}">
-                      <a16:colId xmlns:a16="http://schemas.microsoft.com/office/drawing/2014/main" val="20000"/>
-                    </a:ext>
-                  </a:extLst>
-                </a:gridCol>
-                <a:gridCol w="1188720">
-                  <a:extLst>
-                    <a:ext uri="{9D8B030D-6E8A-4147-A177-3AD203B41FA5}">
-                      <a16:colId xmlns:a16="http://schemas.microsoft.com/office/drawing/2014/main" val="20001"/>
-                    </a:ext>
-                  </a:extLst>
-                </a:gridCol>
-                <a:gridCol w="1325880">
-                  <a:extLst>
-                    <a:ext uri="{9D8B030D-6E8A-4147-A177-3AD203B41FA5}">
-                      <a16:colId xmlns:a16="http://schemas.microsoft.com/office/drawing/2014/main" val="20002"/>
-                    </a:ext>
-                  </a:extLst>
-                </a:gridCol>
-                <a:gridCol w="1325880">
-                  <a:extLst>
-                    <a:ext uri="{9D8B030D-6E8A-4147-A177-3AD203B41FA5}">
-                      <a16:colId xmlns:a16="http://schemas.microsoft.com/office/drawing/2014/main" val="20003"/>
-                    </a:ext>
-                  </a:extLst>
-                </a:gridCol>
-                <a:gridCol w="1234440">
-                  <a:extLst>
-                    <a:ext uri="{9D8B030D-6E8A-4147-A177-3AD203B41FA5}">
-                      <a16:colId xmlns:a16="http://schemas.microsoft.com/office/drawing/2014/main" val="20004"/>
-                    </a:ext>
-                  </a:extLst>
-                </a:gridCol>
+                <a:gridCol w="2148840"/>
+                <a:gridCol w="1188720"/>
+                <a:gridCol w="1325880"/>
+                <a:gridCol w="1325880"/>
+                <a:gridCol w="1234440"/>
               </a:tblGrid>
               <a:tr h="475488">
                 <a:tc>
                   <a:txBody>
-                    <a:bodyPr/>
+                    <a:bodyPr wrap="square"/>
                     <a:lstStyle/>
                     <a:p>
                       <a:pPr algn="l"/>
@@ -3238,7 +3207,7 @@
                 </a:tc>
                 <a:tc>
                   <a:txBody>
-                    <a:bodyPr/>
+                    <a:bodyPr wrap="square"/>
                     <a:lstStyle/>
                     <a:p>
                       <a:pPr algn="ctr"/>
@@ -3261,7 +3230,7 @@
                 </a:tc>
                 <a:tc>
                   <a:txBody>
-                    <a:bodyPr/>
+                    <a:bodyPr wrap="square"/>
                     <a:lstStyle/>
                     <a:p>
                       <a:pPr algn="ctr"/>
@@ -3284,7 +3253,7 @@
                 </a:tc>
                 <a:tc>
                   <a:txBody>
-                    <a:bodyPr/>
+                    <a:bodyPr wrap="square"/>
                     <a:lstStyle/>
                     <a:p>
                       <a:pPr algn="ctr"/>
@@ -3307,7 +3276,7 @@
                 </a:tc>
                 <a:tc>
                   <a:txBody>
-                    <a:bodyPr/>
+                    <a:bodyPr wrap="square"/>
                     <a:lstStyle/>
                     <a:p>
                       <a:pPr algn="ctr"/>
@@ -3328,16 +3297,11 @@
                     </a:solidFill>
                   </a:tcPr>
                 </a:tc>
-                <a:extLst>
-                  <a:ext uri="{0D108BD9-81ED-4DB2-BD59-A6C34878D82A}">
-                    <a16:rowId xmlns:a16="http://schemas.microsoft.com/office/drawing/2014/main" val="10000"/>
-                  </a:ext>
-                </a:extLst>
               </a:tr>
               <a:tr h="475488">
                 <a:tc>
                   <a:txBody>
-                    <a:bodyPr/>
+                    <a:bodyPr wrap="square"/>
                     <a:lstStyle/>
                     <a:p>
                       <a:pPr algn="l"/>
@@ -3359,7 +3323,7 @@
                 </a:tc>
                 <a:tc>
                   <a:txBody>
-                    <a:bodyPr/>
+                    <a:bodyPr wrap="square"/>
                     <a:lstStyle/>
                     <a:p>
                       <a:pPr algn="ctr"/>
@@ -3381,7 +3345,7 @@
                 </a:tc>
                 <a:tc>
                   <a:txBody>
-                    <a:bodyPr/>
+                    <a:bodyPr wrap="square"/>
                     <a:lstStyle/>
                     <a:p>
                       <a:pPr algn="r"/>
@@ -3403,7 +3367,7 @@
                 </a:tc>
                 <a:tc>
                   <a:txBody>
-                    <a:bodyPr/>
+                    <a:bodyPr wrap="square"/>
                     <a:lstStyle/>
                     <a:p>
                       <a:pPr algn="r"/>
@@ -3425,7 +3389,7 @@
                 </a:tc>
                 <a:tc>
                   <a:txBody>
-                    <a:bodyPr/>
+                    <a:bodyPr wrap="square"/>
                     <a:lstStyle/>
                     <a:p>
                       <a:pPr algn="r"/>
@@ -3445,16 +3409,11 @@
                     </a:solidFill>
                   </a:tcPr>
                 </a:tc>
-                <a:extLst>
-                  <a:ext uri="{0D108BD9-81ED-4DB2-BD59-A6C34878D82A}">
-                    <a16:rowId xmlns:a16="http://schemas.microsoft.com/office/drawing/2014/main" val="10001"/>
-                  </a:ext>
-                </a:extLst>
               </a:tr>
               <a:tr h="475488">
                 <a:tc>
                   <a:txBody>
-                    <a:bodyPr/>
+                    <a:bodyPr wrap="square"/>
                     <a:lstStyle/>
                     <a:p>
                       <a:pPr algn="l"/>
@@ -3476,7 +3435,7 @@
                 </a:tc>
                 <a:tc>
                   <a:txBody>
-                    <a:bodyPr/>
+                    <a:bodyPr wrap="square"/>
                     <a:lstStyle/>
                     <a:p>
                       <a:pPr algn="ctr"/>
@@ -3498,7 +3457,7 @@
                 </a:tc>
                 <a:tc>
                   <a:txBody>
-                    <a:bodyPr/>
+                    <a:bodyPr wrap="square"/>
                     <a:lstStyle/>
                     <a:p>
                       <a:pPr algn="r"/>
@@ -3520,7 +3479,7 @@
                 </a:tc>
                 <a:tc>
                   <a:txBody>
-                    <a:bodyPr/>
+                    <a:bodyPr wrap="square"/>
                     <a:lstStyle/>
                     <a:p>
                       <a:pPr algn="r"/>
@@ -3542,7 +3501,7 @@
                 </a:tc>
                 <a:tc>
                   <a:txBody>
-                    <a:bodyPr/>
+                    <a:bodyPr wrap="square"/>
                     <a:lstStyle/>
                     <a:p>
                       <a:pPr algn="r"/>
@@ -3562,16 +3521,11 @@
                     </a:solidFill>
                   </a:tcPr>
                 </a:tc>
-                <a:extLst>
-                  <a:ext uri="{0D108BD9-81ED-4DB2-BD59-A6C34878D82A}">
-                    <a16:rowId xmlns:a16="http://schemas.microsoft.com/office/drawing/2014/main" val="10002"/>
-                  </a:ext>
-                </a:extLst>
               </a:tr>
               <a:tr h="475488">
                 <a:tc>
                   <a:txBody>
-                    <a:bodyPr/>
+                    <a:bodyPr wrap="square"/>
                     <a:lstStyle/>
                     <a:p>
                       <a:pPr algn="l"/>
@@ -3593,7 +3547,7 @@
                 </a:tc>
                 <a:tc>
                   <a:txBody>
-                    <a:bodyPr/>
+                    <a:bodyPr wrap="square"/>
                     <a:lstStyle/>
                     <a:p>
                       <a:pPr algn="ctr"/>
@@ -3615,7 +3569,7 @@
                 </a:tc>
                 <a:tc>
                   <a:txBody>
-                    <a:bodyPr/>
+                    <a:bodyPr wrap="square"/>
                     <a:lstStyle/>
                     <a:p>
                       <a:pPr algn="r"/>
@@ -3637,7 +3591,7 @@
                 </a:tc>
                 <a:tc>
                   <a:txBody>
-                    <a:bodyPr/>
+                    <a:bodyPr wrap="square"/>
                     <a:lstStyle/>
                     <a:p>
                       <a:pPr algn="r"/>
@@ -3659,7 +3613,7 @@
                 </a:tc>
                 <a:tc>
                   <a:txBody>
-                    <a:bodyPr/>
+                    <a:bodyPr wrap="square"/>
                     <a:lstStyle/>
                     <a:p>
                       <a:pPr algn="r"/>
@@ -3679,16 +3633,11 @@
                     </a:solidFill>
                   </a:tcPr>
                 </a:tc>
-                <a:extLst>
-                  <a:ext uri="{0D108BD9-81ED-4DB2-BD59-A6C34878D82A}">
-                    <a16:rowId xmlns:a16="http://schemas.microsoft.com/office/drawing/2014/main" val="10003"/>
-                  </a:ext>
-                </a:extLst>
               </a:tr>
               <a:tr h="475488">
                 <a:tc>
                   <a:txBody>
-                    <a:bodyPr/>
+                    <a:bodyPr wrap="square"/>
                     <a:lstStyle/>
                     <a:p>
                       <a:pPr algn="l"/>
@@ -3710,7 +3659,7 @@
                 </a:tc>
                 <a:tc>
                   <a:txBody>
-                    <a:bodyPr/>
+                    <a:bodyPr wrap="square"/>
                     <a:lstStyle/>
                     <a:p>
                       <a:pPr algn="ctr"/>
@@ -3732,7 +3681,7 @@
                 </a:tc>
                 <a:tc>
                   <a:txBody>
-                    <a:bodyPr/>
+                    <a:bodyPr wrap="square"/>
                     <a:lstStyle/>
                     <a:p>
                       <a:pPr algn="r"/>
@@ -3754,7 +3703,7 @@
                 </a:tc>
                 <a:tc>
                   <a:txBody>
-                    <a:bodyPr/>
+                    <a:bodyPr wrap="square"/>
                     <a:lstStyle/>
                     <a:p>
                       <a:pPr algn="r"/>
@@ -3776,7 +3725,7 @@
                 </a:tc>
                 <a:tc>
                   <a:txBody>
-                    <a:bodyPr/>
+                    <a:bodyPr wrap="square"/>
                     <a:lstStyle/>
                     <a:p>
                       <a:pPr algn="r"/>
@@ -3796,11 +3745,6 @@
                     </a:solidFill>
                   </a:tcPr>
                 </a:tc>
-                <a:extLst>
-                  <a:ext uri="{0D108BD9-81ED-4DB2-BD59-A6C34878D82A}">
-                    <a16:rowId xmlns:a16="http://schemas.microsoft.com/office/drawing/2014/main" val="10004"/>
-                  </a:ext>
-                </a:extLst>
               </a:tr>
             </a:tbl>
           </a:graphicData>
@@ -3814,7 +3758,7 @@
         </p:nvSpPr>
         <p:spPr>
           <a:xfrm>
-            <a:off x="274320" y="3564032"/>
+            <a:off x="274320" y="3703320"/>
             <a:ext cx="7498079" cy="365760"/>
           </a:xfrm>
           <a:prstGeom prst="rect">
@@ -3829,7 +3773,7 @@
           <a:lstStyle/>
           <a:p>
             <a:r>
-              <a:rPr sz="1200" b="1" dirty="0">
+              <a:rPr sz="1200" b="1">
                 <a:solidFill>
                   <a:srgbClr val="335588"/>
                 </a:solidFill>
@@ -3848,7 +3792,7 @@
           <p:nvPr/>
         </p:nvGraphicFramePr>
         <p:xfrm>
-          <a:off x="274320" y="3977639"/>
+          <a:off x="274320" y="4160520"/>
           <a:ext cx="6035040" cy="1280160"/>
         </p:xfrm>
         <a:graphic>
@@ -3858,25 +3802,13 @@
                 <a:tableStyleId>{5C22544A-7EE6-4342-B048-85BDC9FD1C3A}</a:tableStyleId>
               </a:tblPr>
               <a:tblGrid>
-                <a:gridCol w="4617720">
-                  <a:extLst>
-                    <a:ext uri="{9D8B030D-6E8A-4147-A177-3AD203B41FA5}">
-                      <a16:colId xmlns:a16="http://schemas.microsoft.com/office/drawing/2014/main" val="20000"/>
-                    </a:ext>
-                  </a:extLst>
-                </a:gridCol>
-                <a:gridCol w="1417320">
-                  <a:extLst>
-                    <a:ext uri="{9D8B030D-6E8A-4147-A177-3AD203B41FA5}">
-                      <a16:colId xmlns:a16="http://schemas.microsoft.com/office/drawing/2014/main" val="20001"/>
-                    </a:ext>
-                  </a:extLst>
-                </a:gridCol>
+                <a:gridCol w="4617720"/>
+                <a:gridCol w="1417320"/>
               </a:tblGrid>
               <a:tr h="426720">
                 <a:tc>
                   <a:txBody>
-                    <a:bodyPr/>
+                    <a:bodyPr wrap="square"/>
                     <a:lstStyle/>
                     <a:p>
                       <a:pPr algn="l"/>
@@ -3898,7 +3830,7 @@
                 </a:tc>
                 <a:tc>
                   <a:txBody>
-                    <a:bodyPr/>
+                    <a:bodyPr wrap="square"/>
                     <a:lstStyle/>
                     <a:p>
                       <a:pPr algn="r"/>
@@ -3918,16 +3850,11 @@
                     </a:solidFill>
                   </a:tcPr>
                 </a:tc>
-                <a:extLst>
-                  <a:ext uri="{0D108BD9-81ED-4DB2-BD59-A6C34878D82A}">
-                    <a16:rowId xmlns:a16="http://schemas.microsoft.com/office/drawing/2014/main" val="10000"/>
-                  </a:ext>
-                </a:extLst>
               </a:tr>
               <a:tr h="426720">
                 <a:tc>
                   <a:txBody>
-                    <a:bodyPr/>
+                    <a:bodyPr wrap="square"/>
                     <a:lstStyle/>
                     <a:p>
                       <a:pPr algn="l"/>
@@ -3949,7 +3876,7 @@
                 </a:tc>
                 <a:tc>
                   <a:txBody>
-                    <a:bodyPr/>
+                    <a:bodyPr wrap="square"/>
                     <a:lstStyle/>
                     <a:p>
                       <a:pPr algn="r"/>
@@ -3969,16 +3896,11 @@
                     </a:solidFill>
                   </a:tcPr>
                 </a:tc>
-                <a:extLst>
-                  <a:ext uri="{0D108BD9-81ED-4DB2-BD59-A6C34878D82A}">
-                    <a16:rowId xmlns:a16="http://schemas.microsoft.com/office/drawing/2014/main" val="10001"/>
-                  </a:ext>
-                </a:extLst>
               </a:tr>
               <a:tr h="426720">
                 <a:tc>
                   <a:txBody>
-                    <a:bodyPr/>
+                    <a:bodyPr wrap="square"/>
                     <a:lstStyle/>
                     <a:p>
                       <a:pPr algn="l"/>
@@ -4000,7 +3922,7 @@
                 </a:tc>
                 <a:tc>
                   <a:txBody>
-                    <a:bodyPr/>
+                    <a:bodyPr wrap="square"/>
                     <a:lstStyle/>
                     <a:p>
                       <a:pPr algn="r"/>
@@ -4020,11 +3942,6 @@
                     </a:solidFill>
                   </a:tcPr>
                 </a:tc>
-                <a:extLst>
-                  <a:ext uri="{0D108BD9-81ED-4DB2-BD59-A6C34878D82A}">
-                    <a16:rowId xmlns:a16="http://schemas.microsoft.com/office/drawing/2014/main" val="10002"/>
-                  </a:ext>
-                </a:extLst>
               </a:tr>
             </a:tbl>
           </a:graphicData>
@@ -4038,8 +3955,8 @@
         </p:nvSpPr>
         <p:spPr>
           <a:xfrm>
-            <a:off x="7498080" y="1117285"/>
-            <a:ext cx="4505723" cy="2428870"/>
+            <a:off x="7726679" y="1188720"/>
+            <a:ext cx="4206240" cy="4937760"/>
           </a:xfrm>
           <a:prstGeom prst="rect">
             <a:avLst/>
@@ -4053,7 +3970,7 @@
           <a:lstStyle/>
           <a:p>
             <a:r>
-              <a:rPr sz="1300" b="1" dirty="0">
+              <a:rPr sz="1300" b="1">
                 <a:solidFill>
                   <a:srgbClr val="335588"/>
                 </a:solidFill>
@@ -4068,7 +3985,7 @@
               </a:spcBef>
             </a:pPr>
             <a:r>
-              <a:rPr sz="1050" b="1" dirty="0">
+              <a:rPr sz="1050" b="1">
                 <a:solidFill>
                   <a:srgbClr val="1F3050"/>
                 </a:solidFill>
@@ -4076,7 +3993,7 @@
               <a:t>▪ Both are closed frontier models.  </a:t>
             </a:r>
             <a:r>
-              <a:rPr sz="1050" dirty="0">
+              <a:rPr sz="1050">
                 <a:solidFill>
                   <a:srgbClr val="555555"/>
                 </a:solidFill>
@@ -4091,7 +4008,7 @@
               </a:spcBef>
             </a:pPr>
             <a:r>
-              <a:rPr sz="1050" b="1" dirty="0">
+              <a:rPr sz="1050" b="1">
                 <a:solidFill>
                   <a:srgbClr val="1F3050"/>
                 </a:solidFill>
@@ -4099,7 +4016,7 @@
               <a:t>▪ Sonnet is the pricier anchor.  </a:t>
             </a:r>
             <a:r>
-              <a:rPr sz="1050" dirty="0">
+              <a:rPr sz="1050">
                 <a:solidFill>
                   <a:srgbClr val="555555"/>
                 </a:solidFill>
@@ -4114,7 +4031,7 @@
               </a:spcBef>
             </a:pPr>
             <a:r>
-              <a:rPr sz="1050" b="1" dirty="0">
+              <a:rPr sz="1050" b="1">
                 <a:solidFill>
                   <a:srgbClr val="1F3050"/>
                 </a:solidFill>
@@ -4122,7 +4039,7 @@
               <a:t>▪ Qwen-Flash is cheapest but redundant.  </a:t>
             </a:r>
             <a:r>
-              <a:rPr sz="1050" dirty="0">
+              <a:rPr sz="1050">
                 <a:solidFill>
                   <a:srgbClr val="555555"/>
                 </a:solidFill>
@@ -4137,7 +4054,7 @@
               </a:spcBef>
             </a:pPr>
             <a:r>
-              <a:rPr sz="1050" b="1" dirty="0">
+              <a:rPr sz="1050" b="1">
                 <a:solidFill>
                   <a:srgbClr val="1F3050"/>
                 </a:solidFill>
@@ -4145,7 +4062,7 @@
               <a:t>▪ Levers save ~30%, not more.  </a:t>
             </a:r>
             <a:r>
-              <a:rPr sz="1050" dirty="0">
+              <a:rPr sz="1050">
                 <a:solidFill>
                   <a:srgbClr val="555555"/>
                 </a:solidFill>
@@ -4197,7 +4114,7 @@
 </file>
 
 <file path=ppt/slides/slide2.xml><?xml version="1.0" encoding="utf-8"?>
-<p:sld xmlns:a="http://schemas.openxmlformats.org/drawingml/2006/main" xmlns:r="http://schemas.openxmlformats.org/officeDocument/2006/relationships" xmlns:p="http://schemas.openxmlformats.org/presentationml/2006/main">
+<p:sld xmlns:a="http://schemas.openxmlformats.org/drawingml/2006/main" xmlns:p="http://schemas.openxmlformats.org/presentationml/2006/main" xmlns:r="http://schemas.openxmlformats.org/officeDocument/2006/relationships">
   <p:cSld>
     <p:spTree>
       <p:nvGrpSpPr>
@@ -4205,14 +4122,7 @@
         <p:cNvGrpSpPr/>
         <p:nvPr/>
       </p:nvGrpSpPr>
-      <p:grpSpPr>
-        <a:xfrm>
-          <a:off x="0" y="0"/>
-          <a:ext cx="0" cy="0"/>
-          <a:chOff x="0" y="0"/>
-          <a:chExt cx="0" cy="0"/>
-        </a:xfrm>
-      </p:grpSpPr>
+      <p:grpSpPr/>
       <p:sp>
         <p:nvSpPr>
           <p:cNvPr id="2" name="TextBox 1"/>
@@ -4298,67 +4208,19 @@
                 <a:tableStyleId>{5C22544A-7EE6-4342-B048-85BDC9FD1C3A}</a:tableStyleId>
               </a:tblPr>
               <a:tblGrid>
-                <a:gridCol w="2148840">
-                  <a:extLst>
-                    <a:ext uri="{9D8B030D-6E8A-4147-A177-3AD203B41FA5}">
-                      <a16:colId xmlns:a16="http://schemas.microsoft.com/office/drawing/2014/main" val="20000"/>
-                    </a:ext>
-                  </a:extLst>
-                </a:gridCol>
-                <a:gridCol w="960120">
-                  <a:extLst>
-                    <a:ext uri="{9D8B030D-6E8A-4147-A177-3AD203B41FA5}">
-                      <a16:colId xmlns:a16="http://schemas.microsoft.com/office/drawing/2014/main" val="20001"/>
-                    </a:ext>
-                  </a:extLst>
-                </a:gridCol>
-                <a:gridCol w="960120">
-                  <a:extLst>
-                    <a:ext uri="{9D8B030D-6E8A-4147-A177-3AD203B41FA5}">
-                      <a16:colId xmlns:a16="http://schemas.microsoft.com/office/drawing/2014/main" val="20002"/>
-                    </a:ext>
-                  </a:extLst>
-                </a:gridCol>
-                <a:gridCol w="960120">
-                  <a:extLst>
-                    <a:ext uri="{9D8B030D-6E8A-4147-A177-3AD203B41FA5}">
-                      <a16:colId xmlns:a16="http://schemas.microsoft.com/office/drawing/2014/main" val="20003"/>
-                    </a:ext>
-                  </a:extLst>
-                </a:gridCol>
-                <a:gridCol w="960120">
-                  <a:extLst>
-                    <a:ext uri="{9D8B030D-6E8A-4147-A177-3AD203B41FA5}">
-                      <a16:colId xmlns:a16="http://schemas.microsoft.com/office/drawing/2014/main" val="20004"/>
-                    </a:ext>
-                  </a:extLst>
-                </a:gridCol>
-                <a:gridCol w="960120">
-                  <a:extLst>
-                    <a:ext uri="{9D8B030D-6E8A-4147-A177-3AD203B41FA5}">
-                      <a16:colId xmlns:a16="http://schemas.microsoft.com/office/drawing/2014/main" val="20005"/>
-                    </a:ext>
-                  </a:extLst>
-                </a:gridCol>
-                <a:gridCol w="960120">
-                  <a:extLst>
-                    <a:ext uri="{9D8B030D-6E8A-4147-A177-3AD203B41FA5}">
-                      <a16:colId xmlns:a16="http://schemas.microsoft.com/office/drawing/2014/main" val="20006"/>
-                    </a:ext>
-                  </a:extLst>
-                </a:gridCol>
-                <a:gridCol w="914400">
-                  <a:extLst>
-                    <a:ext uri="{9D8B030D-6E8A-4147-A177-3AD203B41FA5}">
-                      <a16:colId xmlns:a16="http://schemas.microsoft.com/office/drawing/2014/main" val="20007"/>
-                    </a:ext>
-                  </a:extLst>
-                </a:gridCol>
+                <a:gridCol w="2148840"/>
+                <a:gridCol w="960120"/>
+                <a:gridCol w="960120"/>
+                <a:gridCol w="960120"/>
+                <a:gridCol w="960120"/>
+                <a:gridCol w="960120"/>
+                <a:gridCol w="960120"/>
+                <a:gridCol w="914400"/>
               </a:tblGrid>
               <a:tr h="418011">
                 <a:tc>
                   <a:txBody>
-                    <a:bodyPr/>
+                    <a:bodyPr wrap="square"/>
                     <a:lstStyle/>
                     <a:p>
                       <a:pPr algn="l"/>
@@ -4380,7 +4242,7 @@
                 </a:tc>
                 <a:tc>
                   <a:txBody>
-                    <a:bodyPr/>
+                    <a:bodyPr wrap="square"/>
                     <a:lstStyle/>
                     <a:p>
                       <a:pPr algn="ctr"/>
@@ -4403,7 +4265,7 @@
                 </a:tc>
                 <a:tc>
                   <a:txBody>
-                    <a:bodyPr/>
+                    <a:bodyPr wrap="square"/>
                     <a:lstStyle/>
                     <a:p>
                       <a:pPr algn="ctr"/>
@@ -4426,7 +4288,7 @@
                 </a:tc>
                 <a:tc>
                   <a:txBody>
-                    <a:bodyPr/>
+                    <a:bodyPr wrap="square"/>
                     <a:lstStyle/>
                     <a:p>
                       <a:pPr algn="ctr"/>
@@ -4449,7 +4311,7 @@
                 </a:tc>
                 <a:tc>
                   <a:txBody>
-                    <a:bodyPr/>
+                    <a:bodyPr wrap="square"/>
                     <a:lstStyle/>
                     <a:p>
                       <a:pPr algn="ctr"/>
@@ -4472,7 +4334,7 @@
                 </a:tc>
                 <a:tc>
                   <a:txBody>
-                    <a:bodyPr/>
+                    <a:bodyPr wrap="square"/>
                     <a:lstStyle/>
                     <a:p>
                       <a:pPr algn="ctr"/>
@@ -4495,7 +4357,7 @@
                 </a:tc>
                 <a:tc>
                   <a:txBody>
-                    <a:bodyPr/>
+                    <a:bodyPr wrap="square"/>
                     <a:lstStyle/>
                     <a:p>
                       <a:pPr algn="ctr"/>
@@ -4518,7 +4380,7 @@
                 </a:tc>
                 <a:tc>
                   <a:txBody>
-                    <a:bodyPr/>
+                    <a:bodyPr wrap="square"/>
                     <a:lstStyle/>
                     <a:p>
                       <a:pPr algn="ctr"/>
@@ -4539,16 +4401,11 @@
                     </a:solidFill>
                   </a:tcPr>
                 </a:tc>
-                <a:extLst>
-                  <a:ext uri="{0D108BD9-81ED-4DB2-BD59-A6C34878D82A}">
-                    <a16:rowId xmlns:a16="http://schemas.microsoft.com/office/drawing/2014/main" val="10000"/>
-                  </a:ext>
-                </a:extLst>
               </a:tr>
               <a:tr h="418011">
                 <a:tc>
                   <a:txBody>
-                    <a:bodyPr/>
+                    <a:bodyPr wrap="square"/>
                     <a:lstStyle/>
                     <a:p>
                       <a:pPr algn="l"/>
@@ -4570,7 +4427,7 @@
                 </a:tc>
                 <a:tc>
                   <a:txBody>
-                    <a:bodyPr/>
+                    <a:bodyPr wrap="square"/>
                     <a:lstStyle/>
                     <a:p>
                       <a:pPr algn="r"/>
@@ -4592,7 +4449,7 @@
                 </a:tc>
                 <a:tc>
                   <a:txBody>
-                    <a:bodyPr/>
+                    <a:bodyPr wrap="square"/>
                     <a:lstStyle/>
                     <a:p>
                       <a:pPr algn="r"/>
@@ -4614,7 +4471,7 @@
                 </a:tc>
                 <a:tc>
                   <a:txBody>
-                    <a:bodyPr/>
+                    <a:bodyPr wrap="square"/>
                     <a:lstStyle/>
                     <a:p>
                       <a:pPr algn="r"/>
@@ -4636,7 +4493,7 @@
                 </a:tc>
                 <a:tc>
                   <a:txBody>
-                    <a:bodyPr/>
+                    <a:bodyPr wrap="square"/>
                     <a:lstStyle/>
                     <a:p>
                       <a:pPr algn="r"/>
@@ -4658,7 +4515,7 @@
                 </a:tc>
                 <a:tc>
                   <a:txBody>
-                    <a:bodyPr/>
+                    <a:bodyPr wrap="square"/>
                     <a:lstStyle/>
                     <a:p>
                       <a:pPr algn="r"/>
@@ -4680,7 +4537,7 @@
                 </a:tc>
                 <a:tc>
                   <a:txBody>
-                    <a:bodyPr/>
+                    <a:bodyPr wrap="square"/>
                     <a:lstStyle/>
                     <a:p>
                       <a:pPr algn="r"/>
@@ -4702,7 +4559,7 @@
                 </a:tc>
                 <a:tc>
                   <a:txBody>
-                    <a:bodyPr/>
+                    <a:bodyPr wrap="square"/>
                     <a:lstStyle/>
                     <a:p>
                       <a:pPr algn="r"/>
@@ -4722,16 +4579,11 @@
                     </a:solidFill>
                   </a:tcPr>
                 </a:tc>
-                <a:extLst>
-                  <a:ext uri="{0D108BD9-81ED-4DB2-BD59-A6C34878D82A}">
-                    <a16:rowId xmlns:a16="http://schemas.microsoft.com/office/drawing/2014/main" val="10001"/>
-                  </a:ext>
-                </a:extLst>
               </a:tr>
               <a:tr h="418011">
                 <a:tc>
                   <a:txBody>
-                    <a:bodyPr/>
+                    <a:bodyPr wrap="square"/>
                     <a:lstStyle/>
                     <a:p>
                       <a:pPr algn="l"/>
@@ -4753,7 +4605,7 @@
                 </a:tc>
                 <a:tc>
                   <a:txBody>
-                    <a:bodyPr/>
+                    <a:bodyPr wrap="square"/>
                     <a:lstStyle/>
                     <a:p>
                       <a:pPr algn="r"/>
@@ -4775,7 +4627,7 @@
                 </a:tc>
                 <a:tc>
                   <a:txBody>
-                    <a:bodyPr/>
+                    <a:bodyPr wrap="square"/>
                     <a:lstStyle/>
                     <a:p>
                       <a:pPr algn="r"/>
@@ -4797,7 +4649,7 @@
                 </a:tc>
                 <a:tc>
                   <a:txBody>
-                    <a:bodyPr/>
+                    <a:bodyPr wrap="square"/>
                     <a:lstStyle/>
                     <a:p>
                       <a:pPr algn="r"/>
@@ -4819,7 +4671,7 @@
                 </a:tc>
                 <a:tc>
                   <a:txBody>
-                    <a:bodyPr/>
+                    <a:bodyPr wrap="square"/>
                     <a:lstStyle/>
                     <a:p>
                       <a:pPr algn="r"/>
@@ -4841,7 +4693,7 @@
                 </a:tc>
                 <a:tc>
                   <a:txBody>
-                    <a:bodyPr/>
+                    <a:bodyPr wrap="square"/>
                     <a:lstStyle/>
                     <a:p>
                       <a:pPr algn="r"/>
@@ -4863,7 +4715,7 @@
                 </a:tc>
                 <a:tc>
                   <a:txBody>
-                    <a:bodyPr/>
+                    <a:bodyPr wrap="square"/>
                     <a:lstStyle/>
                     <a:p>
                       <a:pPr algn="r"/>
@@ -4885,7 +4737,7 @@
                 </a:tc>
                 <a:tc>
                   <a:txBody>
-                    <a:bodyPr/>
+                    <a:bodyPr wrap="square"/>
                     <a:lstStyle/>
                     <a:p>
                       <a:pPr algn="r"/>
@@ -4905,16 +4757,11 @@
                     </a:solidFill>
                   </a:tcPr>
                 </a:tc>
-                <a:extLst>
-                  <a:ext uri="{0D108BD9-81ED-4DB2-BD59-A6C34878D82A}">
-                    <a16:rowId xmlns:a16="http://schemas.microsoft.com/office/drawing/2014/main" val="10002"/>
-                  </a:ext>
-                </a:extLst>
               </a:tr>
               <a:tr h="418011">
                 <a:tc>
                   <a:txBody>
-                    <a:bodyPr/>
+                    <a:bodyPr wrap="square"/>
                     <a:lstStyle/>
                     <a:p>
                       <a:pPr algn="l"/>
@@ -4936,7 +4783,7 @@
                 </a:tc>
                 <a:tc>
                   <a:txBody>
-                    <a:bodyPr/>
+                    <a:bodyPr wrap="square"/>
                     <a:lstStyle/>
                     <a:p>
                       <a:pPr algn="r"/>
@@ -4958,7 +4805,7 @@
                 </a:tc>
                 <a:tc>
                   <a:txBody>
-                    <a:bodyPr/>
+                    <a:bodyPr wrap="square"/>
                     <a:lstStyle/>
                     <a:p>
                       <a:pPr algn="r"/>
@@ -4980,7 +4827,7 @@
                 </a:tc>
                 <a:tc>
                   <a:txBody>
-                    <a:bodyPr/>
+                    <a:bodyPr wrap="square"/>
                     <a:lstStyle/>
                     <a:p>
                       <a:pPr algn="r"/>
@@ -5002,7 +4849,7 @@
                 </a:tc>
                 <a:tc>
                   <a:txBody>
-                    <a:bodyPr/>
+                    <a:bodyPr wrap="square"/>
                     <a:lstStyle/>
                     <a:p>
                       <a:pPr algn="r"/>
@@ -5024,7 +4871,7 @@
                 </a:tc>
                 <a:tc>
                   <a:txBody>
-                    <a:bodyPr/>
+                    <a:bodyPr wrap="square"/>
                     <a:lstStyle/>
                     <a:p>
                       <a:pPr algn="r"/>
@@ -5046,7 +4893,7 @@
                 </a:tc>
                 <a:tc>
                   <a:txBody>
-                    <a:bodyPr/>
+                    <a:bodyPr wrap="square"/>
                     <a:lstStyle/>
                     <a:p>
                       <a:pPr algn="r"/>
@@ -5068,7 +4915,7 @@
                 </a:tc>
                 <a:tc>
                   <a:txBody>
-                    <a:bodyPr/>
+                    <a:bodyPr wrap="square"/>
                     <a:lstStyle/>
                     <a:p>
                       <a:pPr algn="r"/>
@@ -5088,16 +4935,11 @@
                     </a:solidFill>
                   </a:tcPr>
                 </a:tc>
-                <a:extLst>
-                  <a:ext uri="{0D108BD9-81ED-4DB2-BD59-A6C34878D82A}">
-                    <a16:rowId xmlns:a16="http://schemas.microsoft.com/office/drawing/2014/main" val="10003"/>
-                  </a:ext>
-                </a:extLst>
               </a:tr>
               <a:tr h="418011">
                 <a:tc>
                   <a:txBody>
-                    <a:bodyPr/>
+                    <a:bodyPr wrap="square"/>
                     <a:lstStyle/>
                     <a:p>
                       <a:pPr algn="l"/>
@@ -5119,7 +4961,7 @@
                 </a:tc>
                 <a:tc>
                   <a:txBody>
-                    <a:bodyPr/>
+                    <a:bodyPr wrap="square"/>
                     <a:lstStyle/>
                     <a:p>
                       <a:pPr algn="r"/>
@@ -5141,7 +4983,7 @@
                 </a:tc>
                 <a:tc>
                   <a:txBody>
-                    <a:bodyPr/>
+                    <a:bodyPr wrap="square"/>
                     <a:lstStyle/>
                     <a:p>
                       <a:pPr algn="r"/>
@@ -5163,7 +5005,7 @@
                 </a:tc>
                 <a:tc>
                   <a:txBody>
-                    <a:bodyPr/>
+                    <a:bodyPr wrap="square"/>
                     <a:lstStyle/>
                     <a:p>
                       <a:pPr algn="r"/>
@@ -5185,7 +5027,7 @@
                 </a:tc>
                 <a:tc>
                   <a:txBody>
-                    <a:bodyPr/>
+                    <a:bodyPr wrap="square"/>
                     <a:lstStyle/>
                     <a:p>
                       <a:pPr algn="r"/>
@@ -5207,7 +5049,7 @@
                 </a:tc>
                 <a:tc>
                   <a:txBody>
-                    <a:bodyPr/>
+                    <a:bodyPr wrap="square"/>
                     <a:lstStyle/>
                     <a:p>
                       <a:pPr algn="r"/>
@@ -5229,7 +5071,7 @@
                 </a:tc>
                 <a:tc>
                   <a:txBody>
-                    <a:bodyPr/>
+                    <a:bodyPr wrap="square"/>
                     <a:lstStyle/>
                     <a:p>
                       <a:pPr algn="r"/>
@@ -5251,7 +5093,7 @@
                 </a:tc>
                 <a:tc>
                   <a:txBody>
-                    <a:bodyPr/>
+                    <a:bodyPr wrap="square"/>
                     <a:lstStyle/>
                     <a:p>
                       <a:pPr algn="r"/>
@@ -5271,16 +5113,11 @@
                     </a:solidFill>
                   </a:tcPr>
                 </a:tc>
-                <a:extLst>
-                  <a:ext uri="{0D108BD9-81ED-4DB2-BD59-A6C34878D82A}">
-                    <a16:rowId xmlns:a16="http://schemas.microsoft.com/office/drawing/2014/main" val="10004"/>
-                  </a:ext>
-                </a:extLst>
               </a:tr>
               <a:tr h="418011">
                 <a:tc>
                   <a:txBody>
-                    <a:bodyPr/>
+                    <a:bodyPr wrap="square"/>
                     <a:lstStyle/>
                     <a:p>
                       <a:pPr algn="l"/>
@@ -5302,7 +5139,7 @@
                 </a:tc>
                 <a:tc>
                   <a:txBody>
-                    <a:bodyPr/>
+                    <a:bodyPr wrap="square"/>
                     <a:lstStyle/>
                     <a:p>
                       <a:pPr algn="r"/>
@@ -5324,7 +5161,7 @@
                 </a:tc>
                 <a:tc>
                   <a:txBody>
-                    <a:bodyPr/>
+                    <a:bodyPr wrap="square"/>
                     <a:lstStyle/>
                     <a:p>
                       <a:pPr algn="r"/>
@@ -5346,7 +5183,7 @@
                 </a:tc>
                 <a:tc>
                   <a:txBody>
-                    <a:bodyPr/>
+                    <a:bodyPr wrap="square"/>
                     <a:lstStyle/>
                     <a:p>
                       <a:pPr algn="r"/>
@@ -5368,7 +5205,7 @@
                 </a:tc>
                 <a:tc>
                   <a:txBody>
-                    <a:bodyPr/>
+                    <a:bodyPr wrap="square"/>
                     <a:lstStyle/>
                     <a:p>
                       <a:pPr algn="r"/>
@@ -5390,7 +5227,7 @@
                 </a:tc>
                 <a:tc>
                   <a:txBody>
-                    <a:bodyPr/>
+                    <a:bodyPr wrap="square"/>
                     <a:lstStyle/>
                     <a:p>
                       <a:pPr algn="r"/>
@@ -5412,7 +5249,7 @@
                 </a:tc>
                 <a:tc>
                   <a:txBody>
-                    <a:bodyPr/>
+                    <a:bodyPr wrap="square"/>
                     <a:lstStyle/>
                     <a:p>
                       <a:pPr algn="r"/>
@@ -5434,7 +5271,7 @@
                 </a:tc>
                 <a:tc>
                   <a:txBody>
-                    <a:bodyPr/>
+                    <a:bodyPr wrap="square"/>
                     <a:lstStyle/>
                     <a:p>
                       <a:pPr algn="r"/>
@@ -5454,16 +5291,11 @@
                     </a:solidFill>
                   </a:tcPr>
                 </a:tc>
-                <a:extLst>
-                  <a:ext uri="{0D108BD9-81ED-4DB2-BD59-A6C34878D82A}">
-                    <a16:rowId xmlns:a16="http://schemas.microsoft.com/office/drawing/2014/main" val="10005"/>
-                  </a:ext>
-                </a:extLst>
               </a:tr>
               <a:tr h="418014">
                 <a:tc>
                   <a:txBody>
-                    <a:bodyPr/>
+                    <a:bodyPr wrap="square"/>
                     <a:lstStyle/>
                     <a:p>
                       <a:pPr algn="l"/>
@@ -5485,7 +5317,7 @@
                 </a:tc>
                 <a:tc>
                   <a:txBody>
-                    <a:bodyPr/>
+                    <a:bodyPr wrap="square"/>
                     <a:lstStyle/>
                     <a:p>
                       <a:pPr algn="r"/>
@@ -5507,11 +5339,18 @@
                 </a:tc>
                 <a:tc>
                   <a:txBody>
-                    <a:bodyPr/>
+                    <a:bodyPr wrap="square"/>
                     <a:lstStyle/>
                     <a:p>
                       <a:pPr algn="l"/>
-                      <a:endParaRPr/>
+                      <a:r>
+                        <a:rPr sz="1000" b="0">
+                          <a:solidFill>
+                            <a:srgbClr val="1F3050"/>
+                          </a:solidFill>
+                        </a:rPr>
+                        <a:t/>
+                      </a:r>
                     </a:p>
                   </a:txBody>
                   <a:tcPr marL="54864" marR="54864" marT="18288" marB="18288">
@@ -5522,11 +5361,18 @@
                 </a:tc>
                 <a:tc>
                   <a:txBody>
-                    <a:bodyPr/>
+                    <a:bodyPr wrap="square"/>
                     <a:lstStyle/>
                     <a:p>
                       <a:pPr algn="l"/>
-                      <a:endParaRPr/>
+                      <a:r>
+                        <a:rPr sz="1000" b="0">
+                          <a:solidFill>
+                            <a:srgbClr val="1F3050"/>
+                          </a:solidFill>
+                        </a:rPr>
+                        <a:t/>
+                      </a:r>
                     </a:p>
                   </a:txBody>
                   <a:tcPr marL="54864" marR="54864" marT="18288" marB="18288">
@@ -5537,7 +5383,7 @@
                 </a:tc>
                 <a:tc>
                   <a:txBody>
-                    <a:bodyPr/>
+                    <a:bodyPr wrap="square"/>
                     <a:lstStyle/>
                     <a:p>
                       <a:pPr algn="r"/>
@@ -5559,7 +5405,7 @@
                 </a:tc>
                 <a:tc>
                   <a:txBody>
-                    <a:bodyPr/>
+                    <a:bodyPr wrap="square"/>
                     <a:lstStyle/>
                     <a:p>
                       <a:pPr algn="r"/>
@@ -5581,7 +5427,7 @@
                 </a:tc>
                 <a:tc>
                   <a:txBody>
-                    <a:bodyPr/>
+                    <a:bodyPr wrap="square"/>
                     <a:lstStyle/>
                     <a:p>
                       <a:pPr algn="r"/>
@@ -5603,7 +5449,7 @@
                 </a:tc>
                 <a:tc>
                   <a:txBody>
-                    <a:bodyPr/>
+                    <a:bodyPr wrap="square"/>
                     <a:lstStyle/>
                     <a:p>
                       <a:pPr algn="r"/>
@@ -5623,11 +5469,6 @@
                     </a:solidFill>
                   </a:tcPr>
                 </a:tc>
-                <a:extLst>
-                  <a:ext uri="{0D108BD9-81ED-4DB2-BD59-A6C34878D82A}">
-                    <a16:rowId xmlns:a16="http://schemas.microsoft.com/office/drawing/2014/main" val="10006"/>
-                  </a:ext>
-                </a:extLst>
               </a:tr>
             </a:tbl>
           </a:graphicData>
@@ -5777,7 +5618,7 @@
 </file>
 
 <file path=ppt/slides/slide3.xml><?xml version="1.0" encoding="utf-8"?>
-<p:sld xmlns:a="http://schemas.openxmlformats.org/drawingml/2006/main" xmlns:r="http://schemas.openxmlformats.org/officeDocument/2006/relationships" xmlns:p="http://schemas.openxmlformats.org/presentationml/2006/main">
+<p:sld xmlns:a="http://schemas.openxmlformats.org/drawingml/2006/main" xmlns:p="http://schemas.openxmlformats.org/presentationml/2006/main" xmlns:r="http://schemas.openxmlformats.org/officeDocument/2006/relationships">
   <p:cSld>
     <p:spTree>
       <p:nvGrpSpPr>
@@ -5785,14 +5626,7 @@
         <p:cNvGrpSpPr/>
         <p:nvPr/>
       </p:nvGrpSpPr>
-      <p:grpSpPr>
-        <a:xfrm>
-          <a:off x="0" y="0"/>
-          <a:ext cx="0" cy="0"/>
-          <a:chOff x="0" y="0"/>
-          <a:chExt cx="0" cy="0"/>
-        </a:xfrm>
-      </p:grpSpPr>
+      <p:grpSpPr/>
       <p:sp>
         <p:nvSpPr>
           <p:cNvPr id="2" name="TextBox 1"/>
@@ -5878,39 +5712,15 @@
                 <a:tableStyleId>{5C22544A-7EE6-4342-B048-85BDC9FD1C3A}</a:tableStyleId>
               </a:tblPr>
               <a:tblGrid>
-                <a:gridCol w="3154680">
-                  <a:extLst>
-                    <a:ext uri="{9D8B030D-6E8A-4147-A177-3AD203B41FA5}">
-                      <a16:colId xmlns:a16="http://schemas.microsoft.com/office/drawing/2014/main" val="20000"/>
-                    </a:ext>
-                  </a:extLst>
-                </a:gridCol>
-                <a:gridCol w="1143000">
-                  <a:extLst>
-                    <a:ext uri="{9D8B030D-6E8A-4147-A177-3AD203B41FA5}">
-                      <a16:colId xmlns:a16="http://schemas.microsoft.com/office/drawing/2014/main" val="20001"/>
-                    </a:ext>
-                  </a:extLst>
-                </a:gridCol>
-                <a:gridCol w="1600200">
-                  <a:extLst>
-                    <a:ext uri="{9D8B030D-6E8A-4147-A177-3AD203B41FA5}">
-                      <a16:colId xmlns:a16="http://schemas.microsoft.com/office/drawing/2014/main" val="20002"/>
-                    </a:ext>
-                  </a:extLst>
-                </a:gridCol>
-                <a:gridCol w="4160520">
-                  <a:extLst>
-                    <a:ext uri="{9D8B030D-6E8A-4147-A177-3AD203B41FA5}">
-                      <a16:colId xmlns:a16="http://schemas.microsoft.com/office/drawing/2014/main" val="20003"/>
-                    </a:ext>
-                  </a:extLst>
-                </a:gridCol>
+                <a:gridCol w="3154680"/>
+                <a:gridCol w="1143000"/>
+                <a:gridCol w="1600200"/>
+                <a:gridCol w="4160520"/>
               </a:tblGrid>
               <a:tr h="375920">
                 <a:tc>
                   <a:txBody>
-                    <a:bodyPr/>
+                    <a:bodyPr wrap="square"/>
                     <a:lstStyle/>
                     <a:p>
                       <a:pPr algn="l"/>
@@ -5932,7 +5742,7 @@
                 </a:tc>
                 <a:tc>
                   <a:txBody>
-                    <a:bodyPr/>
+                    <a:bodyPr wrap="square"/>
                     <a:lstStyle/>
                     <a:p>
                       <a:pPr algn="ctr"/>
@@ -5954,7 +5764,7 @@
                 </a:tc>
                 <a:tc>
                   <a:txBody>
-                    <a:bodyPr/>
+                    <a:bodyPr wrap="square"/>
                     <a:lstStyle/>
                     <a:p>
                       <a:pPr algn="ctr"/>
@@ -5976,7 +5786,7 @@
                 </a:tc>
                 <a:tc>
                   <a:txBody>
-                    <a:bodyPr/>
+                    <a:bodyPr wrap="square"/>
                     <a:lstStyle/>
                     <a:p>
                       <a:pPr algn="l"/>
@@ -5996,16 +5806,11 @@
                     </a:solidFill>
                   </a:tcPr>
                 </a:tc>
-                <a:extLst>
-                  <a:ext uri="{0D108BD9-81ED-4DB2-BD59-A6C34878D82A}">
-                    <a16:rowId xmlns:a16="http://schemas.microsoft.com/office/drawing/2014/main" val="10000"/>
-                  </a:ext>
-                </a:extLst>
               </a:tr>
               <a:tr h="375920">
                 <a:tc>
                   <a:txBody>
-                    <a:bodyPr/>
+                    <a:bodyPr wrap="square"/>
                     <a:lstStyle/>
                     <a:p>
                       <a:pPr algn="l"/>
@@ -6027,7 +5832,7 @@
                 </a:tc>
                 <a:tc>
                   <a:txBody>
-                    <a:bodyPr/>
+                    <a:bodyPr wrap="square"/>
                     <a:lstStyle/>
                     <a:p>
                       <a:pPr algn="ctr"/>
@@ -6049,7 +5854,7 @@
                 </a:tc>
                 <a:tc>
                   <a:txBody>
-                    <a:bodyPr/>
+                    <a:bodyPr wrap="square"/>
                     <a:lstStyle/>
                     <a:p>
                       <a:pPr algn="r"/>
@@ -6071,7 +5876,7 @@
                 </a:tc>
                 <a:tc>
                   <a:txBody>
-                    <a:bodyPr/>
+                    <a:bodyPr wrap="square"/>
                     <a:lstStyle/>
                     <a:p>
                       <a:pPr algn="l"/>
@@ -6091,16 +5896,11 @@
                     </a:solidFill>
                   </a:tcPr>
                 </a:tc>
-                <a:extLst>
-                  <a:ext uri="{0D108BD9-81ED-4DB2-BD59-A6C34878D82A}">
-                    <a16:rowId xmlns:a16="http://schemas.microsoft.com/office/drawing/2014/main" val="10001"/>
-                  </a:ext>
-                </a:extLst>
               </a:tr>
               <a:tr h="375920">
                 <a:tc>
                   <a:txBody>
-                    <a:bodyPr/>
+                    <a:bodyPr wrap="square"/>
                     <a:lstStyle/>
                     <a:p>
                       <a:pPr algn="l"/>
@@ -6122,7 +5922,7 @@
                 </a:tc>
                 <a:tc>
                   <a:txBody>
-                    <a:bodyPr/>
+                    <a:bodyPr wrap="square"/>
                     <a:lstStyle/>
                     <a:p>
                       <a:pPr algn="ctr"/>
@@ -6144,7 +5944,7 @@
                 </a:tc>
                 <a:tc>
                   <a:txBody>
-                    <a:bodyPr/>
+                    <a:bodyPr wrap="square"/>
                     <a:lstStyle/>
                     <a:p>
                       <a:pPr algn="r"/>
@@ -6166,7 +5966,7 @@
                 </a:tc>
                 <a:tc>
                   <a:txBody>
-                    <a:bodyPr/>
+                    <a:bodyPr wrap="square"/>
                     <a:lstStyle/>
                     <a:p>
                       <a:pPr algn="l"/>
@@ -6186,16 +5986,11 @@
                     </a:solidFill>
                   </a:tcPr>
                 </a:tc>
-                <a:extLst>
-                  <a:ext uri="{0D108BD9-81ED-4DB2-BD59-A6C34878D82A}">
-                    <a16:rowId xmlns:a16="http://schemas.microsoft.com/office/drawing/2014/main" val="10002"/>
-                  </a:ext>
-                </a:extLst>
               </a:tr>
               <a:tr h="375920">
                 <a:tc>
                   <a:txBody>
-                    <a:bodyPr/>
+                    <a:bodyPr wrap="square"/>
                     <a:lstStyle/>
                     <a:p>
                       <a:pPr algn="l"/>
@@ -6217,7 +6012,7 @@
                 </a:tc>
                 <a:tc>
                   <a:txBody>
-                    <a:bodyPr/>
+                    <a:bodyPr wrap="square"/>
                     <a:lstStyle/>
                     <a:p>
                       <a:pPr algn="ctr"/>
@@ -6239,7 +6034,7 @@
                 </a:tc>
                 <a:tc>
                   <a:txBody>
-                    <a:bodyPr/>
+                    <a:bodyPr wrap="square"/>
                     <a:lstStyle/>
                     <a:p>
                       <a:pPr algn="r"/>
@@ -6261,7 +6056,7 @@
                 </a:tc>
                 <a:tc>
                   <a:txBody>
-                    <a:bodyPr/>
+                    <a:bodyPr wrap="square"/>
                     <a:lstStyle/>
                     <a:p>
                       <a:pPr algn="l"/>
@@ -6281,16 +6076,11 @@
                     </a:solidFill>
                   </a:tcPr>
                 </a:tc>
-                <a:extLst>
-                  <a:ext uri="{0D108BD9-81ED-4DB2-BD59-A6C34878D82A}">
-                    <a16:rowId xmlns:a16="http://schemas.microsoft.com/office/drawing/2014/main" val="10003"/>
-                  </a:ext>
-                </a:extLst>
               </a:tr>
               <a:tr h="375920">
                 <a:tc>
                   <a:txBody>
-                    <a:bodyPr/>
+                    <a:bodyPr wrap="square"/>
                     <a:lstStyle/>
                     <a:p>
                       <a:pPr algn="l"/>
@@ -6312,7 +6102,7 @@
                 </a:tc>
                 <a:tc>
                   <a:txBody>
-                    <a:bodyPr/>
+                    <a:bodyPr wrap="square"/>
                     <a:lstStyle/>
                     <a:p>
                       <a:pPr algn="ctr"/>
@@ -6334,7 +6124,7 @@
                 </a:tc>
                 <a:tc>
                   <a:txBody>
-                    <a:bodyPr/>
+                    <a:bodyPr wrap="square"/>
                     <a:lstStyle/>
                     <a:p>
                       <a:pPr algn="r"/>
@@ -6356,7 +6146,7 @@
                 </a:tc>
                 <a:tc>
                   <a:txBody>
-                    <a:bodyPr/>
+                    <a:bodyPr wrap="square"/>
                     <a:lstStyle/>
                     <a:p>
                       <a:pPr algn="l"/>
@@ -6376,16 +6166,11 @@
                     </a:solidFill>
                   </a:tcPr>
                 </a:tc>
-                <a:extLst>
-                  <a:ext uri="{0D108BD9-81ED-4DB2-BD59-A6C34878D82A}">
-                    <a16:rowId xmlns:a16="http://schemas.microsoft.com/office/drawing/2014/main" val="10004"/>
-                  </a:ext>
-                </a:extLst>
               </a:tr>
               <a:tr h="375920">
                 <a:tc>
                   <a:txBody>
-                    <a:bodyPr/>
+                    <a:bodyPr wrap="square"/>
                     <a:lstStyle/>
                     <a:p>
                       <a:pPr algn="l"/>
@@ -6407,7 +6192,7 @@
                 </a:tc>
                 <a:tc>
                   <a:txBody>
-                    <a:bodyPr/>
+                    <a:bodyPr wrap="square"/>
                     <a:lstStyle/>
                     <a:p>
                       <a:pPr algn="ctr"/>
@@ -6429,7 +6214,7 @@
                 </a:tc>
                 <a:tc>
                   <a:txBody>
-                    <a:bodyPr/>
+                    <a:bodyPr wrap="square"/>
                     <a:lstStyle/>
                     <a:p>
                       <a:pPr algn="r"/>
@@ -6451,7 +6236,7 @@
                 </a:tc>
                 <a:tc>
                   <a:txBody>
-                    <a:bodyPr/>
+                    <a:bodyPr wrap="square"/>
                     <a:lstStyle/>
                     <a:p>
                       <a:pPr algn="l"/>
@@ -6471,16 +6256,11 @@
                     </a:solidFill>
                   </a:tcPr>
                 </a:tc>
-                <a:extLst>
-                  <a:ext uri="{0D108BD9-81ED-4DB2-BD59-A6C34878D82A}">
-                    <a16:rowId xmlns:a16="http://schemas.microsoft.com/office/drawing/2014/main" val="10005"/>
-                  </a:ext>
-                </a:extLst>
               </a:tr>
               <a:tr h="375920">
                 <a:tc>
                   <a:txBody>
-                    <a:bodyPr/>
+                    <a:bodyPr wrap="square"/>
                     <a:lstStyle/>
                     <a:p>
                       <a:pPr algn="l"/>
@@ -6502,7 +6282,7 @@
                 </a:tc>
                 <a:tc>
                   <a:txBody>
-                    <a:bodyPr/>
+                    <a:bodyPr wrap="square"/>
                     <a:lstStyle/>
                     <a:p>
                       <a:pPr algn="ctr"/>
@@ -6524,7 +6304,7 @@
                 </a:tc>
                 <a:tc>
                   <a:txBody>
-                    <a:bodyPr/>
+                    <a:bodyPr wrap="square"/>
                     <a:lstStyle/>
                     <a:p>
                       <a:pPr algn="r"/>
@@ -6546,7 +6326,7 @@
                 </a:tc>
                 <a:tc>
                   <a:txBody>
-                    <a:bodyPr/>
+                    <a:bodyPr wrap="square"/>
                     <a:lstStyle/>
                     <a:p>
                       <a:pPr algn="l"/>
@@ -6566,16 +6346,11 @@
                     </a:solidFill>
                   </a:tcPr>
                 </a:tc>
-                <a:extLst>
-                  <a:ext uri="{0D108BD9-81ED-4DB2-BD59-A6C34878D82A}">
-                    <a16:rowId xmlns:a16="http://schemas.microsoft.com/office/drawing/2014/main" val="10006"/>
-                  </a:ext>
-                </a:extLst>
               </a:tr>
               <a:tr h="375920">
                 <a:tc>
                   <a:txBody>
-                    <a:bodyPr/>
+                    <a:bodyPr wrap="square"/>
                     <a:lstStyle/>
                     <a:p>
                       <a:pPr algn="l"/>
@@ -6597,12 +6372,12 @@
                 </a:tc>
                 <a:tc>
                   <a:txBody>
-                    <a:bodyPr/>
+                    <a:bodyPr wrap="square"/>
                     <a:lstStyle/>
                     <a:p>
                       <a:pPr algn="ctr"/>
                       <a:r>
-                        <a:rPr sz="1100" b="1" dirty="0">
+                        <a:rPr sz="1100" b="1">
                           <a:solidFill>
                             <a:srgbClr val="335588"/>
                           </a:solidFill>
@@ -6619,12 +6394,12 @@
                 </a:tc>
                 <a:tc>
                   <a:txBody>
-                    <a:bodyPr/>
+                    <a:bodyPr wrap="square"/>
                     <a:lstStyle/>
                     <a:p>
                       <a:pPr algn="r"/>
                       <a:r>
-                        <a:rPr sz="1050" b="0" dirty="0">
+                        <a:rPr sz="1050" b="0">
                           <a:solidFill>
                             <a:srgbClr val="1F3050"/>
                           </a:solidFill>
@@ -6641,12 +6416,12 @@
                 </a:tc>
                 <a:tc>
                   <a:txBody>
-                    <a:bodyPr/>
+                    <a:bodyPr wrap="square"/>
                     <a:lstStyle/>
                     <a:p>
                       <a:pPr algn="l"/>
                       <a:r>
-                        <a:rPr sz="950" b="0" dirty="0">
+                        <a:rPr sz="950" b="0">
                           <a:solidFill>
                             <a:srgbClr val="555555"/>
                           </a:solidFill>
@@ -6661,16 +6436,11 @@
                     </a:solidFill>
                   </a:tcPr>
                 </a:tc>
-                <a:extLst>
-                  <a:ext uri="{0D108BD9-81ED-4DB2-BD59-A6C34878D82A}">
-                    <a16:rowId xmlns:a16="http://schemas.microsoft.com/office/drawing/2014/main" val="10007"/>
-                  </a:ext>
-                </a:extLst>
               </a:tr>
               <a:tr h="375920">
                 <a:tc>
                   <a:txBody>
-                    <a:bodyPr/>
+                    <a:bodyPr wrap="square"/>
                     <a:lstStyle/>
                     <a:p>
                       <a:pPr algn="l"/>
@@ -6692,7 +6462,7 @@
                 </a:tc>
                 <a:tc>
                   <a:txBody>
-                    <a:bodyPr/>
+                    <a:bodyPr wrap="square"/>
                     <a:lstStyle/>
                     <a:p>
                       <a:pPr algn="ctr"/>
@@ -6714,7 +6484,7 @@
                 </a:tc>
                 <a:tc>
                   <a:txBody>
-                    <a:bodyPr/>
+                    <a:bodyPr wrap="square"/>
                     <a:lstStyle/>
                     <a:p>
                       <a:pPr algn="r"/>
@@ -6736,12 +6506,12 @@
                 </a:tc>
                 <a:tc>
                   <a:txBody>
-                    <a:bodyPr/>
+                    <a:bodyPr wrap="square"/>
                     <a:lstStyle/>
                     <a:p>
                       <a:pPr algn="l"/>
                       <a:r>
-                        <a:rPr sz="950" b="0" dirty="0">
+                        <a:rPr sz="950" b="0">
                           <a:solidFill>
                             <a:srgbClr val="555555"/>
                           </a:solidFill>
@@ -6756,11 +6526,6 @@
                     </a:solidFill>
                   </a:tcPr>
                 </a:tc>
-                <a:extLst>
-                  <a:ext uri="{0D108BD9-81ED-4DB2-BD59-A6C34878D82A}">
-                    <a16:rowId xmlns:a16="http://schemas.microsoft.com/office/drawing/2014/main" val="10008"/>
-                  </a:ext>
-                </a:extLst>
               </a:tr>
             </a:tbl>
           </a:graphicData>
@@ -6840,7 +6605,7 @@
                   <a:srgbClr val="555555"/>
                 </a:solidFill>
               </a:rPr>
-              <a:t>These stack: keeping both think but cutting structure → ~10% of full (Haiku+Gemini sweep5 $538 → ~$54), with statistical power largely intact.</a:t>
+              <a:t>These stack: keeping both think but cutting structure → ~10% of full (Haiku+Gemini sweep5 $537 → ~$54), with statistical power largely intact.</a:t>
             </a:r>
           </a:p>
         </p:txBody>
@@ -6874,6 +6639,550 @@
                 </a:solidFill>
               </a:rPr>
               <a:t>Scenarios computed on the sweep5 token table. PlanBench scales the same way (its analogue of validate_plan-style cost is the with-tools think-on cell). Cuts are labeled variants — flag any domain/fixture sampling in the writeup.</a:t>
+            </a:r>
+          </a:p>
+        </p:txBody>
+      </p:sp>
+    </p:spTree>
+  </p:cSld>
+  <p:clrMapOvr>
+    <a:masterClrMapping/>
+  </p:clrMapOvr>
+</p:sld>
+</file>
+
+<file path=ppt/slides/slide4.xml><?xml version="1.0" encoding="utf-8"?>
+<p:sld xmlns:a="http://schemas.openxmlformats.org/drawingml/2006/main" xmlns:p="http://schemas.openxmlformats.org/presentationml/2006/main" xmlns:r="http://schemas.openxmlformats.org/officeDocument/2006/relationships">
+  <p:cSld>
+    <p:spTree>
+      <p:nvGrpSpPr>
+        <p:cNvPr id="1" name=""/>
+        <p:cNvGrpSpPr/>
+        <p:nvPr/>
+      </p:nvGrpSpPr>
+      <p:grpSpPr/>
+      <p:sp>
+        <p:nvSpPr>
+          <p:cNvPr id="2" name="TextBox 1"/>
+          <p:cNvSpPr txBox="1"/>
+          <p:nvPr/>
+        </p:nvSpPr>
+        <p:spPr>
+          <a:xfrm>
+            <a:off x="274320" y="164592"/>
+            <a:ext cx="11612880" cy="457200"/>
+          </a:xfrm>
+          <a:prstGeom prst="rect">
+            <a:avLst/>
+          </a:prstGeom>
+          <a:noFill/>
+        </p:spPr>
+        <p:txBody>
+          <a:bodyPr wrap="none">
+            <a:spAutoFit/>
+          </a:bodyPr>
+          <a:lstStyle/>
+          <a:p>
+            <a:r>
+              <a:rPr sz="2200" b="1">
+                <a:solidFill>
+                  <a:srgbClr val="1F3050"/>
+                </a:solidFill>
+              </a:rPr>
+              <a:t>What We Cut vs What Stays Solid</a:t>
+            </a:r>
+          </a:p>
+        </p:txBody>
+      </p:sp>
+      <p:sp>
+        <p:nvSpPr>
+          <p:cNvPr id="3" name="TextBox 2"/>
+          <p:cNvSpPr txBox="1"/>
+          <p:nvPr/>
+        </p:nvSpPr>
+        <p:spPr>
+          <a:xfrm>
+            <a:off x="274320" y="658368"/>
+            <a:ext cx="11612880" cy="365760"/>
+          </a:xfrm>
+          <a:prstGeom prst="rect">
+            <a:avLst/>
+          </a:prstGeom>
+          <a:noFill/>
+        </p:spPr>
+        <p:txBody>
+          <a:bodyPr wrap="none">
+            <a:spAutoFit/>
+          </a:bodyPr>
+          <a:lstStyle/>
+          <a:p>
+            <a:r>
+              <a:rPr sz="1150" i="1">
+                <a:solidFill>
+                  <a:srgbClr val="555555"/>
+                </a:solidFill>
+              </a:rPr>
+              <a:t>Rule of thumb: cut the repeats, keep the spread.  The cuts only remove spares — the comparison stays intact.</a:t>
+            </a:r>
+          </a:p>
+        </p:txBody>
+      </p:sp>
+      <p:sp>
+        <p:nvSpPr>
+          <p:cNvPr id="4" name="Rounded Rectangle 3"/>
+          <p:cNvSpPr/>
+          <p:nvPr/>
+        </p:nvSpPr>
+        <p:spPr>
+          <a:xfrm>
+            <a:off x="274320" y="1325880"/>
+            <a:ext cx="5715000" cy="3703320"/>
+          </a:xfrm>
+          <a:prstGeom prst="roundRect">
+            <a:avLst/>
+          </a:prstGeom>
+          <a:solidFill>
+            <a:srgbClr val="ECF6EC"/>
+          </a:solidFill>
+          <a:ln w="19050">
+            <a:solidFill>
+              <a:srgbClr val="3E823C"/>
+            </a:solidFill>
+          </a:ln>
+          <a:effectLst/>
+        </p:spPr>
+        <p:style>
+          <a:lnRef idx="1">
+            <a:schemeClr val="accent1"/>
+          </a:lnRef>
+          <a:fillRef idx="3">
+            <a:schemeClr val="accent1"/>
+          </a:fillRef>
+          <a:effectRef idx="2">
+            <a:schemeClr val="accent1"/>
+          </a:effectRef>
+          <a:fontRef idx="minor">
+            <a:schemeClr val="lt1"/>
+          </a:fontRef>
+        </p:style>
+        <p:txBody>
+          <a:bodyPr rtlCol="0" anchor="ctr"/>
+          <a:lstStyle/>
+          <a:p>
+            <a:pPr algn="ctr"/>
+          </a:p>
+        </p:txBody>
+      </p:sp>
+      <p:sp>
+        <p:nvSpPr>
+          <p:cNvPr id="5" name="TextBox 4"/>
+          <p:cNvSpPr txBox="1"/>
+          <p:nvPr/>
+        </p:nvSpPr>
+        <p:spPr>
+          <a:xfrm>
+            <a:off x="530352" y="1527048"/>
+            <a:ext cx="5202936" cy="3300984"/>
+          </a:xfrm>
+          <a:prstGeom prst="rect">
+            <a:avLst/>
+          </a:prstGeom>
+          <a:noFill/>
+        </p:spPr>
+        <p:txBody>
+          <a:bodyPr wrap="square">
+            <a:spAutoFit/>
+          </a:bodyPr>
+          <a:lstStyle/>
+          <a:p>
+            <a:r>
+              <a:rPr sz="1500" b="1">
+                <a:solidFill>
+                  <a:srgbClr val="3E823C"/>
+                </a:solidFill>
+              </a:rPr>
+              <a:t>✓  KEEP — this IS the experiment</a:t>
+            </a:r>
+          </a:p>
+          <a:p>
+            <a:pPr>
+              <a:spcBef>
+                <a:spcPts val="900"/>
+              </a:spcBef>
+            </a:pPr>
+            <a:r>
+              <a:rPr sz="1150" b="1">
+                <a:solidFill>
+                  <a:srgbClr val="1F3050"/>
+                </a:solidFill>
+              </a:rPr>
+              <a:t>• Tools vs no-tools.  </a:t>
+            </a:r>
+            <a:r>
+              <a:rPr sz="1150">
+                <a:solidFill>
+                  <a:srgbClr val="555555"/>
+                </a:solidFill>
+              </a:rPr>
+              <a:t>the whole question — drop it and there's no experiment.</a:t>
+            </a:r>
+          </a:p>
+          <a:p>
+            <a:pPr>
+              <a:spcBef>
+                <a:spcPts val="900"/>
+              </a:spcBef>
+            </a:pPr>
+            <a:r>
+              <a:rPr sz="1150" b="1">
+                <a:solidFill>
+                  <a:srgbClr val="1F3050"/>
+                </a:solidFill>
+              </a:rPr>
+              <a:t>• Both world-families.  </a:t>
+            </a:r>
+            <a:r>
+              <a:rPr sz="1150">
+                <a:solidFill>
+                  <a:srgbClr val="555555"/>
+                </a:solidFill>
+              </a:rPr>
+              <a:t>keep some classical AND some numeric, or you can't claim it generalizes.</a:t>
+            </a:r>
+          </a:p>
+          <a:p>
+            <a:pPr>
+              <a:spcBef>
+                <a:spcPts val="900"/>
+              </a:spcBef>
+            </a:pPr>
+            <a:r>
+              <a:rPr sz="1150" b="1">
+                <a:solidFill>
+                  <a:srgbClr val="1F3050"/>
+                </a:solidFill>
+              </a:rPr>
+              <a:t>• Both think on / off (ideally).  </a:t>
+            </a:r>
+            <a:r>
+              <a:rPr sz="1150">
+                <a:solidFill>
+                  <a:srgbClr val="555555"/>
+                </a:solidFill>
+              </a:rPr>
+              <a:t>a real research question, and only a 2× cost.</a:t>
+            </a:r>
+          </a:p>
+          <a:p>
+            <a:pPr>
+              <a:spcBef>
+                <a:spcPts val="900"/>
+              </a:spcBef>
+            </a:pPr>
+            <a:r>
+              <a:rPr sz="1150" b="1">
+                <a:solidFill>
+                  <a:srgbClr val="1F3050"/>
+                </a:solidFill>
+              </a:rPr>
+              <a:t>• Hundreds of answers per cell.  </a:t>
+            </a:r>
+            <a:r>
+              <a:rPr sz="1150">
+                <a:solidFill>
+                  <a:srgbClr val="555555"/>
+                </a:solidFill>
+              </a:rPr>
+              <a:t>enough for honest confidence bars (Wilson CIs).</a:t>
+            </a:r>
+          </a:p>
+        </p:txBody>
+      </p:sp>
+      <p:sp>
+        <p:nvSpPr>
+          <p:cNvPr id="6" name="Rounded Rectangle 5"/>
+          <p:cNvSpPr/>
+          <p:nvPr/>
+        </p:nvSpPr>
+        <p:spPr>
+          <a:xfrm>
+            <a:off x="6217920" y="1325880"/>
+            <a:ext cx="5696712" cy="3703320"/>
+          </a:xfrm>
+          <a:prstGeom prst="roundRect">
+            <a:avLst/>
+          </a:prstGeom>
+          <a:solidFill>
+            <a:srgbClr val="FBF1DE"/>
+          </a:solidFill>
+          <a:ln w="19050">
+            <a:solidFill>
+              <a:srgbClr val="AE701C"/>
+            </a:solidFill>
+          </a:ln>
+          <a:effectLst/>
+        </p:spPr>
+        <p:style>
+          <a:lnRef idx="1">
+            <a:schemeClr val="accent1"/>
+          </a:lnRef>
+          <a:fillRef idx="3">
+            <a:schemeClr val="accent1"/>
+          </a:fillRef>
+          <a:effectRef idx="2">
+            <a:schemeClr val="accent1"/>
+          </a:effectRef>
+          <a:fontRef idx="minor">
+            <a:schemeClr val="lt1"/>
+          </a:fontRef>
+        </p:style>
+        <p:txBody>
+          <a:bodyPr rtlCol="0" anchor="ctr"/>
+          <a:lstStyle/>
+          <a:p>
+            <a:pPr algn="ctr"/>
+          </a:p>
+        </p:txBody>
+      </p:sp>
+      <p:sp>
+        <p:nvSpPr>
+          <p:cNvPr id="7" name="TextBox 6"/>
+          <p:cNvSpPr txBox="1"/>
+          <p:nvPr/>
+        </p:nvSpPr>
+        <p:spPr>
+          <a:xfrm>
+            <a:off x="6473952" y="1527048"/>
+            <a:ext cx="5184648" cy="3300984"/>
+          </a:xfrm>
+          <a:prstGeom prst="rect">
+            <a:avLst/>
+          </a:prstGeom>
+          <a:noFill/>
+        </p:spPr>
+        <p:txBody>
+          <a:bodyPr wrap="square">
+            <a:spAutoFit/>
+          </a:bodyPr>
+          <a:lstStyle/>
+          <a:p>
+            <a:r>
+              <a:rPr sz="1500" b="1">
+                <a:solidFill>
+                  <a:srgbClr val="AE701C"/>
+                </a:solidFill>
+              </a:rPr>
+              <a:t>✂  SAFE TO CUT — just repeats</a:t>
+            </a:r>
+          </a:p>
+          <a:p>
+            <a:pPr>
+              <a:spcBef>
+                <a:spcPts val="900"/>
+              </a:spcBef>
+            </a:pPr>
+            <a:r>
+              <a:rPr sz="1150" b="1">
+                <a:solidFill>
+                  <a:srgbClr val="1F3050"/>
+                </a:solidFill>
+              </a:rPr>
+              <a:t>• Wordings 6 → 2.  </a:t>
+            </a:r>
+            <a:r>
+              <a:rPr sz="1150">
+                <a:solidFill>
+                  <a:srgbClr val="555555"/>
+                </a:solidFill>
+              </a:rPr>
+              <a:t>keep 2 phrasings; still shows wording doesn't change the result.   ‒52%</a:t>
+            </a:r>
+          </a:p>
+          <a:p>
+            <a:pPr>
+              <a:spcBef>
+                <a:spcPts val="900"/>
+              </a:spcBef>
+            </a:pPr>
+            <a:r>
+              <a:rPr sz="1150" b="1">
+                <a:solidFill>
+                  <a:srgbClr val="1F3050"/>
+                </a:solidFill>
+              </a:rPr>
+              <a:t>• Plan-checks 10 → 4.  </a:t>
+            </a:r>
+            <a:r>
+              <a:rPr sz="1150">
+                <a:solidFill>
+                  <a:srgbClr val="555555"/>
+                </a:solidFill>
+              </a:rPr>
+              <a:t>2 broken + 2 good; still tests both skills.   −40%</a:t>
+            </a:r>
+          </a:p>
+          <a:p>
+            <a:pPr>
+              <a:spcBef>
+                <a:spcPts val="900"/>
+              </a:spcBef>
+            </a:pPr>
+            <a:r>
+              <a:rPr sz="1150" b="1">
+                <a:solidFill>
+                  <a:srgbClr val="1F3050"/>
+                </a:solidFill>
+              </a:rPr>
+              <a:t>• Worlds 20 → 10.  </a:t>
+            </a:r>
+            <a:r>
+              <a:rPr sz="1150">
+                <a:solidFill>
+                  <a:srgbClr val="555555"/>
+                </a:solidFill>
+              </a:rPr>
+              <a:t>keep 5 classical + 5 numeric (balanced).   −50%</a:t>
+            </a:r>
+          </a:p>
+          <a:p>
+            <a:pPr>
+              <a:spcBef>
+                <a:spcPts val="900"/>
+              </a:spcBef>
+            </a:pPr>
+            <a:r>
+              <a:rPr sz="1150" b="1">
+                <a:solidFill>
+                  <a:srgbClr val="1F3050"/>
+                </a:solidFill>
+              </a:rPr>
+              <a:t>• Drop think-on.  </a:t>
+            </a:r>
+            <a:r>
+              <a:rPr sz="1150">
+                <a:solidFill>
+                  <a:srgbClr val="555555"/>
+                </a:solidFill>
+              </a:rPr>
+              <a:t>the single biggest lever.   −64%</a:t>
+            </a:r>
+          </a:p>
+        </p:txBody>
+      </p:sp>
+      <p:sp>
+        <p:nvSpPr>
+          <p:cNvPr id="8" name="Rounded Rectangle 7"/>
+          <p:cNvSpPr/>
+          <p:nvPr/>
+        </p:nvSpPr>
+        <p:spPr>
+          <a:xfrm>
+            <a:off x="274320" y="5285232"/>
+            <a:ext cx="11640312" cy="841248"/>
+          </a:xfrm>
+          <a:prstGeom prst="roundRect">
+            <a:avLst/>
+          </a:prstGeom>
+          <a:solidFill>
+            <a:srgbClr val="335588"/>
+          </a:solidFill>
+          <a:ln>
+            <a:noFill/>
+          </a:ln>
+          <a:effectLst/>
+        </p:spPr>
+        <p:style>
+          <a:lnRef idx="1">
+            <a:schemeClr val="accent1"/>
+          </a:lnRef>
+          <a:fillRef idx="3">
+            <a:schemeClr val="accent1"/>
+          </a:fillRef>
+          <a:effectRef idx="2">
+            <a:schemeClr val="accent1"/>
+          </a:effectRef>
+          <a:fontRef idx="minor">
+            <a:schemeClr val="lt1"/>
+          </a:fontRef>
+        </p:style>
+        <p:txBody>
+          <a:bodyPr rtlCol="0" anchor="ctr"/>
+          <a:lstStyle/>
+          <a:p>
+            <a:pPr algn="ctr"/>
+          </a:p>
+        </p:txBody>
+      </p:sp>
+      <p:sp>
+        <p:nvSpPr>
+          <p:cNvPr id="9" name="TextBox 8"/>
+          <p:cNvSpPr txBox="1"/>
+          <p:nvPr/>
+        </p:nvSpPr>
+        <p:spPr>
+          <a:xfrm>
+            <a:off x="502920" y="5394960"/>
+            <a:ext cx="11247120" cy="640080"/>
+          </a:xfrm>
+          <a:prstGeom prst="rect">
+            <a:avLst/>
+          </a:prstGeom>
+          <a:noFill/>
+        </p:spPr>
+        <p:txBody>
+          <a:bodyPr wrap="square">
+            <a:spAutoFit/>
+          </a:bodyPr>
+          <a:lstStyle/>
+          <a:p>
+            <a:r>
+              <a:rPr sz="1250" b="1">
+                <a:solidFill>
+                  <a:srgbClr val="FFFFFF"/>
+                </a:solidFill>
+              </a:rPr>
+              <a:t>Lean-but-solid recipe:  </a:t>
+            </a:r>
+            <a:r>
+              <a:rPr sz="1250">
+                <a:solidFill>
+                  <a:srgbClr val="DDE6F2"/>
+                </a:solidFill>
+              </a:rPr>
+              <a:t>both models · tools + no-tools · both think · 10 balanced worlds · 2 wordings · 4 plan-checks   →   ~10% of full  (~$54 sweep5, Haiku+Gemini), still with real confidence bars.</a:t>
+            </a:r>
+          </a:p>
+        </p:txBody>
+      </p:sp>
+      <p:sp>
+        <p:nvSpPr>
+          <p:cNvPr id="10" name="TextBox 9"/>
+          <p:cNvSpPr txBox="1"/>
+          <p:nvPr/>
+        </p:nvSpPr>
+        <p:spPr>
+          <a:xfrm>
+            <a:off x="274320" y="6327648"/>
+            <a:ext cx="11612880" cy="457200"/>
+          </a:xfrm>
+          <a:prstGeom prst="rect">
+            <a:avLst/>
+          </a:prstGeom>
+          <a:noFill/>
+        </p:spPr>
+        <p:txBody>
+          <a:bodyPr wrap="square">
+            <a:spAutoFit/>
+          </a:bodyPr>
+          <a:lstStyle/>
+          <a:p>
+            <a:r>
+              <a:rPr sz="850" i="1">
+                <a:solidFill>
+                  <a:srgbClr val="555555"/>
+                </a:solidFill>
+              </a:rPr>
+              <a:t>Cuts are labeled variants — flag any domain/fixture sampling in the writeup. % reductions are model-independent; $ shown for the recommended cheap pair.</a:t>
             </a:r>
           </a:p>
         </p:txBody>

</xml_diff>

<commit_message>
docs(deployment): steady-GPU goal + cost slide 5 (rent one H200, self-host open roster)
New dev approach for running sweep5v2 + PlanBench over the OPEN-model roster
(Qwen3.5-0.8/4/9B, Qwen3.6-35B, maybe gemma4-31B) on a steady neocloud GPU
instead of the queued 3090/RTX-6000 cluster (which can't seat the 35B in BF16).

- cheap_model_cost_slides.py: add slide 5 + GPU-rental data block (H200-141GB
  @ ~$3/hr x 40-50 GPU-hr ~= $120-150; H100-80GB budget). Route comparison
  (free cluster / H200 / H100 / API closed), per-model BF16 fit table, and the
  decision + corpus-isolation constraints. Regenerate the deck (4 -> 5 slides).
- steady_gpu_deployment_handoff.md: goal, decision/why, rejected alternatives,
  integration points (--llm-base-url / VLLM_BASE; api_key="EMPTY" gap), cost,
  constraints, and open items for the next agent's planning + implementation.
- paper_notes_discussions.md: dated entry (corpus isolation is load-bearing).
</commit_message>
<xml_diff>
--- a/development/cost-breakdowns/cheap_model_cost_slides.pptx
+++ b/development/cost-breakdowns/cheap_model_cost_slides.pptx
@@ -9,6 +9,7 @@
     <p:sldId id="257" r:id="rId8"/>
     <p:sldId id="258" r:id="rId9"/>
     <p:sldId id="259" r:id="rId10"/>
+    <p:sldId id="260" r:id="rId11"/>
   </p:sldIdLst>
   <p:sldSz cx="12191695" cy="6858000" type="screen4x3"/>
   <p:notesSz cx="6858000" cy="9144000"/>
@@ -7183,6 +7184,1438 @@
                 </a:solidFill>
               </a:rPr>
               <a:t>Cuts are labeled variants — flag any domain/fixture sampling in the writeup. % reductions are model-independent; $ shown for the recommended cheap pair.</a:t>
+            </a:r>
+          </a:p>
+        </p:txBody>
+      </p:sp>
+    </p:spTree>
+  </p:cSld>
+  <p:clrMapOvr>
+    <a:masterClrMapping/>
+  </p:clrMapOvr>
+</p:sld>
+</file>
+
+<file path=ppt/slides/slide5.xml><?xml version="1.0" encoding="utf-8"?>
+<p:sld xmlns:a="http://schemas.openxmlformats.org/drawingml/2006/main" xmlns:p="http://schemas.openxmlformats.org/presentationml/2006/main" xmlns:r="http://schemas.openxmlformats.org/officeDocument/2006/relationships">
+  <p:cSld>
+    <p:spTree>
+      <p:nvGrpSpPr>
+        <p:cNvPr id="1" name=""/>
+        <p:cNvGrpSpPr/>
+        <p:nvPr/>
+      </p:nvGrpSpPr>
+      <p:grpSpPr/>
+      <p:sp>
+        <p:nvSpPr>
+          <p:cNvPr id="2" name="TextBox 1"/>
+          <p:cNvSpPr txBox="1"/>
+          <p:nvPr/>
+        </p:nvSpPr>
+        <p:spPr>
+          <a:xfrm>
+            <a:off x="274320" y="164592"/>
+            <a:ext cx="11612880" cy="457200"/>
+          </a:xfrm>
+          <a:prstGeom prst="rect">
+            <a:avLst/>
+          </a:prstGeom>
+          <a:noFill/>
+        </p:spPr>
+        <p:txBody>
+          <a:bodyPr wrap="none">
+            <a:spAutoFit/>
+          </a:bodyPr>
+          <a:lstStyle/>
+          <a:p>
+            <a:r>
+              <a:rPr sz="2200" b="1">
+                <a:solidFill>
+                  <a:srgbClr val="1F3050"/>
+                </a:solidFill>
+              </a:rPr>
+              <a:t>Alternative — Rent One Steady GPU, Self-Host the Open Roster</a:t>
+            </a:r>
+          </a:p>
+        </p:txBody>
+      </p:sp>
+      <p:sp>
+        <p:nvSpPr>
+          <p:cNvPr id="3" name="TextBox 2"/>
+          <p:cNvSpPr txBox="1"/>
+          <p:nvPr/>
+        </p:nvSpPr>
+        <p:spPr>
+          <a:xfrm>
+            <a:off x="274320" y="658368"/>
+            <a:ext cx="11612880" cy="365760"/>
+          </a:xfrm>
+          <a:prstGeom prst="rect">
+            <a:avLst/>
+          </a:prstGeom>
+          <a:noFill/>
+        </p:spPr>
+        <p:txBody>
+          <a:bodyPr wrap="none">
+            <a:spAutoFit/>
+          </a:bodyPr>
+          <a:lstStyle/>
+          <a:p>
+            <a:r>
+              <a:rPr sz="1150" i="1">
+                <a:solidFill>
+                  <a:srgbClr val="555555"/>
+                </a:solidFill>
+              </a:rPr>
+              <a:t>Run the OPEN models (Qwen3.5-0.8/4/9B · Qwen3.6-35B · maybe gemma4-31B) on a persistent neocloud box, not the queued 3090/RTX-6000 cluster. Different models &amp; purpose from the API closed-model baseline above — this is the actual experiment roster.</a:t>
+            </a:r>
+          </a:p>
+        </p:txBody>
+      </p:sp>
+      <p:graphicFrame>
+        <p:nvGraphicFramePr>
+          <p:cNvPr id="4" name="Table 3"/>
+          <p:cNvGraphicFramePr>
+            <a:graphicFrameLocks noGrp="1"/>
+          </p:cNvGraphicFramePr>
+          <p:nvPr/>
+        </p:nvGraphicFramePr>
+        <p:xfrm>
+          <a:off x="274320" y="1170432"/>
+          <a:ext cx="11612880" cy="1783080"/>
+        </p:xfrm>
+        <a:graphic>
+          <a:graphicData uri="http://schemas.openxmlformats.org/drawingml/2006/table">
+            <a:tbl>
+              <a:tblPr firstRow="1" bandRow="1">
+                <a:tableStyleId>{5C22544A-7EE6-4342-B048-85BDC9FD1C3A}</a:tableStyleId>
+              </a:tblPr>
+              <a:tblGrid>
+                <a:gridCol w="3246120"/>
+                <a:gridCol w="1417320"/>
+                <a:gridCol w="1143000"/>
+                <a:gridCol w="1417320"/>
+                <a:gridCol w="4389120"/>
+              </a:tblGrid>
+              <a:tr h="356616">
+                <a:tc>
+                  <a:txBody>
+                    <a:bodyPr wrap="square"/>
+                    <a:lstStyle/>
+                    <a:p>
+                      <a:pPr algn="l"/>
+                      <a:r>
+                        <a:rPr sz="1000" b="1">
+                          <a:solidFill>
+                            <a:srgbClr val="FFFFFF"/>
+                          </a:solidFill>
+                        </a:rPr>
+                        <a:t>Route</a:t>
+                      </a:r>
+                    </a:p>
+                  </a:txBody>
+                  <a:tcPr marL="54864" marR="54864" marT="18288" marB="18288">
+                    <a:solidFill>
+                      <a:srgbClr val="335588"/>
+                    </a:solidFill>
+                  </a:tcPr>
+                </a:tc>
+                <a:tc>
+                  <a:txBody>
+                    <a:bodyPr wrap="square"/>
+                    <a:lstStyle/>
+                    <a:p>
+                      <a:pPr algn="ctr"/>
+                      <a:r>
+                        <a:rPr sz="1000" b="1">
+                          <a:solidFill>
+                            <a:srgbClr val="FFFFFF"/>
+                          </a:solidFill>
+                        </a:rPr>
+                        <a:t>GPU/API $</a:t>
+                      </a:r>
+                    </a:p>
+                  </a:txBody>
+                  <a:tcPr marL="54864" marR="54864" marT="18288" marB="18288">
+                    <a:solidFill>
+                      <a:srgbClr val="335588"/>
+                    </a:solidFill>
+                  </a:tcPr>
+                </a:tc>
+                <a:tc>
+                  <a:txBody>
+                    <a:bodyPr wrap="square"/>
+                    <a:lstStyle/>
+                    <a:p>
+                      <a:pPr algn="ctr"/>
+                      <a:r>
+                        <a:rPr sz="1000" b="1">
+                          <a:solidFill>
+                            <a:srgbClr val="FFFFFF"/>
+                          </a:solidFill>
+                        </a:rPr>
+                        <a:t>Steady?</a:t>
+                      </a:r>
+                    </a:p>
+                  </a:txBody>
+                  <a:tcPr marL="54864" marR="54864" marT="18288" marB="18288">
+                    <a:solidFill>
+                      <a:srgbClr val="335588"/>
+                    </a:solidFill>
+                  </a:tcPr>
+                </a:tc>
+                <a:tc>
+                  <a:txBody>
+                    <a:bodyPr wrap="square"/>
+                    <a:lstStyle/>
+                    <a:p>
+                      <a:pPr algn="ctr"/>
+                      <a:r>
+                        <a:rPr sz="1000" b="1">
+                          <a:solidFill>
+                            <a:srgbClr val="FFFFFF"/>
+                          </a:solidFill>
+                        </a:rPr>
+                        <a:t>35B in BF16</a:t>
+                      </a:r>
+                    </a:p>
+                  </a:txBody>
+                  <a:tcPr marL="54864" marR="54864" marT="18288" marB="18288">
+                    <a:solidFill>
+                      <a:srgbClr val="335588"/>
+                    </a:solidFill>
+                  </a:tcPr>
+                </a:tc>
+                <a:tc>
+                  <a:txBody>
+                    <a:bodyPr wrap="square"/>
+                    <a:lstStyle/>
+                    <a:p>
+                      <a:pPr algn="l"/>
+                      <a:r>
+                        <a:rPr sz="1000" b="1">
+                          <a:solidFill>
+                            <a:srgbClr val="FFFFFF"/>
+                          </a:solidFill>
+                        </a:rPr>
+                        <a:t>Backend / moving parts</a:t>
+                      </a:r>
+                    </a:p>
+                  </a:txBody>
+                  <a:tcPr marL="54864" marR="54864" marT="18288" marB="18288">
+                    <a:solidFill>
+                      <a:srgbClr val="335588"/>
+                    </a:solidFill>
+                  </a:tcPr>
+                </a:tc>
+              </a:tr>
+              <a:tr h="356616">
+                <a:tc>
+                  <a:txBody>
+                    <a:bodyPr wrap="square"/>
+                    <a:lstStyle/>
+                    <a:p>
+                      <a:pPr algn="l"/>
+                      <a:r>
+                        <a:rPr sz="1000" b="0">
+                          <a:solidFill>
+                            <a:srgbClr val="1F3050"/>
+                          </a:solidFill>
+                        </a:rPr>
+                        <a:t>Free SLURM cluster (3090/RTX-6000)</a:t>
+                      </a:r>
+                    </a:p>
+                  </a:txBody>
+                  <a:tcPr marL="54864" marR="54864" marT="18288" marB="18288">
+                    <a:solidFill>
+                      <a:srgbClr val="FFFFFF"/>
+                    </a:solidFill>
+                  </a:tcPr>
+                </a:tc>
+                <a:tc>
+                  <a:txBody>
+                    <a:bodyPr wrap="square"/>
+                    <a:lstStyle/>
+                    <a:p>
+                      <a:pPr algn="ctr"/>
+                      <a:r>
+                        <a:rPr sz="1000" b="0">
+                          <a:solidFill>
+                            <a:srgbClr val="1F3050"/>
+                          </a:solidFill>
+                        </a:rPr>
+                        <a:t>$0</a:t>
+                      </a:r>
+                    </a:p>
+                  </a:txBody>
+                  <a:tcPr marL="54864" marR="54864" marT="18288" marB="18288">
+                    <a:solidFill>
+                      <a:srgbClr val="FFFFFF"/>
+                    </a:solidFill>
+                  </a:tcPr>
+                </a:tc>
+                <a:tc>
+                  <a:txBody>
+                    <a:bodyPr wrap="square"/>
+                    <a:lstStyle/>
+                    <a:p>
+                      <a:pPr algn="ctr"/>
+                      <a:r>
+                        <a:rPr sz="1000" b="0">
+                          <a:solidFill>
+                            <a:srgbClr val="555555"/>
+                          </a:solidFill>
+                        </a:rPr>
+                        <a:t>queued</a:t>
+                      </a:r>
+                    </a:p>
+                  </a:txBody>
+                  <a:tcPr marL="54864" marR="54864" marT="18288" marB="18288">
+                    <a:solidFill>
+                      <a:srgbClr val="FFFFFF"/>
+                    </a:solidFill>
+                  </a:tcPr>
+                </a:tc>
+                <a:tc>
+                  <a:txBody>
+                    <a:bodyPr wrap="square"/>
+                    <a:lstStyle/>
+                    <a:p>
+                      <a:pPr algn="ctr"/>
+                      <a:r>
+                        <a:rPr sz="1000" b="0">
+                          <a:solidFill>
+                            <a:srgbClr val="A03030"/>
+                          </a:solidFill>
+                        </a:rPr>
+                        <a:t>✗ can't seat</a:t>
+                      </a:r>
+                    </a:p>
+                  </a:txBody>
+                  <a:tcPr marL="54864" marR="54864" marT="18288" marB="18288">
+                    <a:solidFill>
+                      <a:srgbClr val="FFFFFF"/>
+                    </a:solidFill>
+                  </a:tcPr>
+                </a:tc>
+                <a:tc>
+                  <a:txBody>
+                    <a:bodyPr wrap="square"/>
+                    <a:lstStyle/>
+                    <a:p>
+                      <a:pPr algn="l"/>
+                      <a:r>
+                        <a:rPr sz="950" b="0">
+                          <a:solidFill>
+                            <a:srgbClr val="555555"/>
+                          </a:solidFill>
+                        </a:rPr>
+                        <a:t>shared, mixed configs</a:t>
+                      </a:r>
+                    </a:p>
+                  </a:txBody>
+                  <a:tcPr marL="54864" marR="54864" marT="18288" marB="18288">
+                    <a:solidFill>
+                      <a:srgbClr val="FFFFFF"/>
+                    </a:solidFill>
+                  </a:tcPr>
+                </a:tc>
+              </a:tr>
+              <a:tr h="356616">
+                <a:tc>
+                  <a:txBody>
+                    <a:bodyPr wrap="square"/>
+                    <a:lstStyle/>
+                    <a:p>
+                      <a:pPr algn="l"/>
+                      <a:r>
+                        <a:rPr sz="1000" b="1">
+                          <a:solidFill>
+                            <a:srgbClr val="1F3050"/>
+                          </a:solidFill>
+                        </a:rPr>
+                        <a:t>Rented H200-141GB</a:t>
+                      </a:r>
+                    </a:p>
+                  </a:txBody>
+                  <a:tcPr marL="54864" marR="54864" marT="18288" marB="18288">
+                    <a:solidFill>
+                      <a:srgbClr val="E2F0D9"/>
+                    </a:solidFill>
+                  </a:tcPr>
+                </a:tc>
+                <a:tc>
+                  <a:txBody>
+                    <a:bodyPr wrap="square"/>
+                    <a:lstStyle/>
+                    <a:p>
+                      <a:pPr algn="ctr"/>
+                      <a:r>
+                        <a:rPr sz="1000" b="1">
+                          <a:solidFill>
+                            <a:srgbClr val="335588"/>
+                          </a:solidFill>
+                        </a:rPr>
+                        <a:t>$120-150</a:t>
+                      </a:r>
+                    </a:p>
+                  </a:txBody>
+                  <a:tcPr marL="54864" marR="54864" marT="18288" marB="18288">
+                    <a:solidFill>
+                      <a:srgbClr val="E2F0D9"/>
+                    </a:solidFill>
+                  </a:tcPr>
+                </a:tc>
+                <a:tc>
+                  <a:txBody>
+                    <a:bodyPr wrap="square"/>
+                    <a:lstStyle/>
+                    <a:p>
+                      <a:pPr algn="ctr"/>
+                      <a:r>
+                        <a:rPr sz="1000" b="0">
+                          <a:solidFill>
+                            <a:srgbClr val="555555"/>
+                          </a:solidFill>
+                        </a:rPr>
+                        <a:t>yes</a:t>
+                      </a:r>
+                    </a:p>
+                  </a:txBody>
+                  <a:tcPr marL="54864" marR="54864" marT="18288" marB="18288">
+                    <a:solidFill>
+                      <a:srgbClr val="E2F0D9"/>
+                    </a:solidFill>
+                  </a:tcPr>
+                </a:tc>
+                <a:tc>
+                  <a:txBody>
+                    <a:bodyPr wrap="square"/>
+                    <a:lstStyle/>
+                    <a:p>
+                      <a:pPr algn="ctr"/>
+                      <a:r>
+                        <a:rPr sz="1000" b="0">
+                          <a:solidFill>
+                            <a:srgbClr val="335588"/>
+                          </a:solidFill>
+                        </a:rPr>
+                        <a:t>✓ clean BF16</a:t>
+                      </a:r>
+                    </a:p>
+                  </a:txBody>
+                  <a:tcPr marL="54864" marR="54864" marT="18288" marB="18288">
+                    <a:solidFill>
+                      <a:srgbClr val="E2F0D9"/>
+                    </a:solidFill>
+                  </a:tcPr>
+                </a:tc>
+                <a:tc>
+                  <a:txBody>
+                    <a:bodyPr wrap="square"/>
+                    <a:lstStyle/>
+                    <a:p>
+                      <a:pPr algn="l"/>
+                      <a:r>
+                        <a:rPr sz="950" b="0">
+                          <a:solidFill>
+                            <a:srgbClr val="555555"/>
+                          </a:solidFill>
+                        </a:rPr>
+                        <a:t>one vanilla vLLM · no TP/FP8</a:t>
+                      </a:r>
+                    </a:p>
+                  </a:txBody>
+                  <a:tcPr marL="54864" marR="54864" marT="18288" marB="18288">
+                    <a:solidFill>
+                      <a:srgbClr val="E2F0D9"/>
+                    </a:solidFill>
+                  </a:tcPr>
+                </a:tc>
+              </a:tr>
+              <a:tr h="356616">
+                <a:tc>
+                  <a:txBody>
+                    <a:bodyPr wrap="square"/>
+                    <a:lstStyle/>
+                    <a:p>
+                      <a:pPr algn="l"/>
+                      <a:r>
+                        <a:rPr sz="1000" b="0">
+                          <a:solidFill>
+                            <a:srgbClr val="1F3050"/>
+                          </a:solidFill>
+                        </a:rPr>
+                        <a:t>Rented H100-80GB (budget)</a:t>
+                      </a:r>
+                    </a:p>
+                  </a:txBody>
+                  <a:tcPr marL="54864" marR="54864" marT="18288" marB="18288">
+                    <a:solidFill>
+                      <a:srgbClr val="FFFFFF"/>
+                    </a:solidFill>
+                  </a:tcPr>
+                </a:tc>
+                <a:tc>
+                  <a:txBody>
+                    <a:bodyPr wrap="square"/>
+                    <a:lstStyle/>
+                    <a:p>
+                      <a:pPr algn="ctr"/>
+                      <a:r>
+                        <a:rPr sz="1000" b="0">
+                          <a:solidFill>
+                            <a:srgbClr val="1F3050"/>
+                          </a:solidFill>
+                        </a:rPr>
+                        <a:t>$96-120</a:t>
+                      </a:r>
+                    </a:p>
+                  </a:txBody>
+                  <a:tcPr marL="54864" marR="54864" marT="18288" marB="18288">
+                    <a:solidFill>
+                      <a:srgbClr val="FFFFFF"/>
+                    </a:solidFill>
+                  </a:tcPr>
+                </a:tc>
+                <a:tc>
+                  <a:txBody>
+                    <a:bodyPr wrap="square"/>
+                    <a:lstStyle/>
+                    <a:p>
+                      <a:pPr algn="ctr"/>
+                      <a:r>
+                        <a:rPr sz="1000" b="0">
+                          <a:solidFill>
+                            <a:srgbClr val="555555"/>
+                          </a:solidFill>
+                        </a:rPr>
+                        <a:t>yes</a:t>
+                      </a:r>
+                    </a:p>
+                  </a:txBody>
+                  <a:tcPr marL="54864" marR="54864" marT="18288" marB="18288">
+                    <a:solidFill>
+                      <a:srgbClr val="FFFFFF"/>
+                    </a:solidFill>
+                  </a:tcPr>
+                </a:tc>
+                <a:tc>
+                  <a:txBody>
+                    <a:bodyPr wrap="square"/>
+                    <a:lstStyle/>
+                    <a:p>
+                      <a:pPr algn="ctr"/>
+                      <a:r>
+                        <a:rPr sz="1000" b="0">
+                          <a:solidFill>
+                            <a:srgbClr val="555555"/>
+                          </a:solidFill>
+                        </a:rPr>
+                        <a:t>FP8 / TP=2</a:t>
+                      </a:r>
+                    </a:p>
+                  </a:txBody>
+                  <a:tcPr marL="54864" marR="54864" marT="18288" marB="18288">
+                    <a:solidFill>
+                      <a:srgbClr val="FFFFFF"/>
+                    </a:solidFill>
+                  </a:tcPr>
+                </a:tc>
+                <a:tc>
+                  <a:txBody>
+                    <a:bodyPr wrap="square"/>
+                    <a:lstStyle/>
+                    <a:p>
+                      <a:pPr algn="l"/>
+                      <a:r>
+                        <a:rPr sz="950" b="0">
+                          <a:solidFill>
+                            <a:srgbClr val="555555"/>
+                          </a:solidFill>
+                        </a:rPr>
+                        <a:t>one vLLM · more moving parts</a:t>
+                      </a:r>
+                    </a:p>
+                  </a:txBody>
+                  <a:tcPr marL="54864" marR="54864" marT="18288" marB="18288">
+                    <a:solidFill>
+                      <a:srgbClr val="FFFFFF"/>
+                    </a:solidFill>
+                  </a:tcPr>
+                </a:tc>
+              </a:tr>
+              <a:tr h="356616">
+                <a:tc>
+                  <a:txBody>
+                    <a:bodyPr wrap="square"/>
+                    <a:lstStyle/>
+                    <a:p>
+                      <a:pPr algn="l"/>
+                      <a:r>
+                        <a:rPr sz="1000" b="0">
+                          <a:solidFill>
+                            <a:srgbClr val="1F3050"/>
+                          </a:solidFill>
+                        </a:rPr>
+                        <a:t>API closed models (slides 1-4)</a:t>
+                      </a:r>
+                    </a:p>
+                  </a:txBody>
+                  <a:tcPr marL="54864" marR="54864" marT="18288" marB="18288">
+                    <a:solidFill>
+                      <a:srgbClr val="F2F5FA"/>
+                    </a:solidFill>
+                  </a:tcPr>
+                </a:tc>
+                <a:tc>
+                  <a:txBody>
+                    <a:bodyPr wrap="square"/>
+                    <a:lstStyle/>
+                    <a:p>
+                      <a:pPr algn="ctr"/>
+                      <a:r>
+                        <a:rPr sz="1000" b="0">
+                          <a:solidFill>
+                            <a:srgbClr val="1F3050"/>
+                          </a:solidFill>
+                        </a:rPr>
+                        <a:t>$1,047</a:t>
+                      </a:r>
+                    </a:p>
+                  </a:txBody>
+                  <a:tcPr marL="54864" marR="54864" marT="18288" marB="18288">
+                    <a:solidFill>
+                      <a:srgbClr val="F2F5FA"/>
+                    </a:solidFill>
+                  </a:tcPr>
+                </a:tc>
+                <a:tc>
+                  <a:txBody>
+                    <a:bodyPr wrap="square"/>
+                    <a:lstStyle/>
+                    <a:p>
+                      <a:pPr algn="ctr"/>
+                      <a:r>
+                        <a:rPr sz="1000" b="0">
+                          <a:solidFill>
+                            <a:srgbClr val="555555"/>
+                          </a:solidFill>
+                        </a:rPr>
+                        <a:t>yes</a:t>
+                      </a:r>
+                    </a:p>
+                  </a:txBody>
+                  <a:tcPr marL="54864" marR="54864" marT="18288" marB="18288">
+                    <a:solidFill>
+                      <a:srgbClr val="F2F5FA"/>
+                    </a:solidFill>
+                  </a:tcPr>
+                </a:tc>
+                <a:tc>
+                  <a:txBody>
+                    <a:bodyPr wrap="square"/>
+                    <a:lstStyle/>
+                    <a:p>
+                      <a:pPr algn="ctr"/>
+                      <a:r>
+                        <a:rPr sz="1000" b="0">
+                          <a:solidFill>
+                            <a:srgbClr val="555555"/>
+                          </a:solidFill>
+                        </a:rPr>
+                        <a:t>n/a (closed)</a:t>
+                      </a:r>
+                    </a:p>
+                  </a:txBody>
+                  <a:tcPr marL="54864" marR="54864" marT="18288" marB="18288">
+                    <a:solidFill>
+                      <a:srgbClr val="F2F5FA"/>
+                    </a:solidFill>
+                  </a:tcPr>
+                </a:tc>
+                <a:tc>
+                  <a:txBody>
+                    <a:bodyPr wrap="square"/>
+                    <a:lstStyle/>
+                    <a:p>
+                      <a:pPr algn="l"/>
+                      <a:r>
+                        <a:rPr sz="950" b="0">
+                          <a:solidFill>
+                            <a:srgbClr val="555555"/>
+                          </a:solidFill>
+                        </a:rPr>
+                        <a:t>OpenAI API · by-the-token</a:t>
+                      </a:r>
+                    </a:p>
+                  </a:txBody>
+                  <a:tcPr marL="54864" marR="54864" marT="18288" marB="18288">
+                    <a:solidFill>
+                      <a:srgbClr val="F2F5FA"/>
+                    </a:solidFill>
+                  </a:tcPr>
+                </a:tc>
+              </a:tr>
+            </a:tbl>
+          </a:graphicData>
+        </a:graphic>
+      </p:graphicFrame>
+      <p:sp>
+        <p:nvSpPr>
+          <p:cNvPr id="5" name="TextBox 4"/>
+          <p:cNvSpPr txBox="1"/>
+          <p:nvPr/>
+        </p:nvSpPr>
+        <p:spPr>
+          <a:xfrm>
+            <a:off x="274320" y="3127248"/>
+            <a:ext cx="5212080" cy="292608"/>
+          </a:xfrm>
+          <a:prstGeom prst="rect">
+            <a:avLst/>
+          </a:prstGeom>
+          <a:noFill/>
+        </p:spPr>
+        <p:txBody>
+          <a:bodyPr wrap="none">
+            <a:spAutoFit/>
+          </a:bodyPr>
+          <a:lstStyle/>
+          <a:p>
+            <a:r>
+              <a:rPr sz="1200" b="1">
+                <a:solidFill>
+                  <a:srgbClr val="335588"/>
+                </a:solidFill>
+              </a:rPr>
+              <a:t>Per-model BF16 fit (served one at a time)</a:t>
+            </a:r>
+          </a:p>
+        </p:txBody>
+      </p:sp>
+      <p:graphicFrame>
+        <p:nvGraphicFramePr>
+          <p:cNvPr id="6" name="Table 5"/>
+          <p:cNvGraphicFramePr>
+            <a:graphicFrameLocks noGrp="1"/>
+          </p:cNvGraphicFramePr>
+          <p:nvPr/>
+        </p:nvGraphicFramePr>
+        <p:xfrm>
+          <a:off x="274320" y="3456432"/>
+          <a:ext cx="5212080" cy="1874519"/>
+        </p:xfrm>
+        <a:graphic>
+          <a:graphicData uri="http://schemas.openxmlformats.org/drawingml/2006/table">
+            <a:tbl>
+              <a:tblPr firstRow="1" bandRow="1">
+                <a:tableStyleId>{5C22544A-7EE6-4342-B048-85BDC9FD1C3A}</a:tableStyleId>
+              </a:tblPr>
+              <a:tblGrid>
+                <a:gridCol w="1783080"/>
+                <a:gridCol w="960120"/>
+                <a:gridCol w="1188720"/>
+                <a:gridCol w="1280160"/>
+              </a:tblGrid>
+              <a:tr h="312419">
+                <a:tc>
+                  <a:txBody>
+                    <a:bodyPr wrap="square"/>
+                    <a:lstStyle/>
+                    <a:p>
+                      <a:pPr algn="l"/>
+                      <a:r>
+                        <a:rPr sz="950" b="1">
+                          <a:solidFill>
+                            <a:srgbClr val="FFFFFF"/>
+                          </a:solidFill>
+                        </a:rPr>
+                        <a:t>Open model</a:t>
+                      </a:r>
+                    </a:p>
+                  </a:txBody>
+                  <a:tcPr marL="54864" marR="54864" marT="18288" marB="18288">
+                    <a:solidFill>
+                      <a:srgbClr val="335588"/>
+                    </a:solidFill>
+                  </a:tcPr>
+                </a:tc>
+                <a:tc>
+                  <a:txBody>
+                    <a:bodyPr wrap="square"/>
+                    <a:lstStyle/>
+                    <a:p>
+                      <a:pPr algn="ctr"/>
+                      <a:r>
+                        <a:rPr sz="950" b="1">
+                          <a:solidFill>
+                            <a:srgbClr val="FFFFFF"/>
+                          </a:solidFill>
+                        </a:rPr>
+                        <a:t>BF16 GB</a:t>
+                      </a:r>
+                    </a:p>
+                  </a:txBody>
+                  <a:tcPr marL="54864" marR="54864" marT="18288" marB="18288">
+                    <a:solidFill>
+                      <a:srgbClr val="335588"/>
+                    </a:solidFill>
+                  </a:tcPr>
+                </a:tc>
+                <a:tc>
+                  <a:txBody>
+                    <a:bodyPr wrap="square"/>
+                    <a:lstStyle/>
+                    <a:p>
+                      <a:pPr algn="ctr"/>
+                      <a:r>
+                        <a:rPr sz="950" b="1">
+                          <a:solidFill>
+                            <a:srgbClr val="FFFFFF"/>
+                          </a:solidFill>
+                        </a:rPr>
+                        <a:t>H200-141</a:t>
+                      </a:r>
+                    </a:p>
+                  </a:txBody>
+                  <a:tcPr marL="54864" marR="54864" marT="18288" marB="18288">
+                    <a:solidFill>
+                      <a:srgbClr val="335588"/>
+                    </a:solidFill>
+                  </a:tcPr>
+                </a:tc>
+                <a:tc>
+                  <a:txBody>
+                    <a:bodyPr wrap="square"/>
+                    <a:lstStyle/>
+                    <a:p>
+                      <a:pPr algn="ctr"/>
+                      <a:r>
+                        <a:rPr sz="950" b="1">
+                          <a:solidFill>
+                            <a:srgbClr val="FFFFFF"/>
+                          </a:solidFill>
+                        </a:rPr>
+                        <a:t>H100-80</a:t>
+                      </a:r>
+                    </a:p>
+                  </a:txBody>
+                  <a:tcPr marL="54864" marR="54864" marT="18288" marB="18288">
+                    <a:solidFill>
+                      <a:srgbClr val="335588"/>
+                    </a:solidFill>
+                  </a:tcPr>
+                </a:tc>
+              </a:tr>
+              <a:tr h="312419">
+                <a:tc>
+                  <a:txBody>
+                    <a:bodyPr wrap="square"/>
+                    <a:lstStyle/>
+                    <a:p>
+                      <a:pPr algn="l"/>
+                      <a:r>
+                        <a:rPr sz="950" b="0">
+                          <a:solidFill>
+                            <a:srgbClr val="1F3050"/>
+                          </a:solidFill>
+                        </a:rPr>
+                        <a:t>Qwen3.5-0.8B</a:t>
+                      </a:r>
+                    </a:p>
+                  </a:txBody>
+                  <a:tcPr marL="54864" marR="54864" marT="18288" marB="18288">
+                    <a:solidFill>
+                      <a:srgbClr val="FFFFFF"/>
+                    </a:solidFill>
+                  </a:tcPr>
+                </a:tc>
+                <a:tc>
+                  <a:txBody>
+                    <a:bodyPr wrap="square"/>
+                    <a:lstStyle/>
+                    <a:p>
+                      <a:pPr algn="r"/>
+                      <a:r>
+                        <a:rPr sz="950" b="0">
+                          <a:solidFill>
+                            <a:srgbClr val="555555"/>
+                          </a:solidFill>
+                        </a:rPr>
+                        <a:t>1.6</a:t>
+                      </a:r>
+                    </a:p>
+                  </a:txBody>
+                  <a:tcPr marL="54864" marR="54864" marT="18288" marB="18288">
+                    <a:solidFill>
+                      <a:srgbClr val="FFFFFF"/>
+                    </a:solidFill>
+                  </a:tcPr>
+                </a:tc>
+                <a:tc>
+                  <a:txBody>
+                    <a:bodyPr wrap="square"/>
+                    <a:lstStyle/>
+                    <a:p>
+                      <a:pPr algn="ctr"/>
+                      <a:r>
+                        <a:rPr sz="950" b="0">
+                          <a:solidFill>
+                            <a:srgbClr val="3E823C"/>
+                          </a:solidFill>
+                        </a:rPr>
+                        <a:t>✓</a:t>
+                      </a:r>
+                    </a:p>
+                  </a:txBody>
+                  <a:tcPr marL="54864" marR="54864" marT="18288" marB="18288">
+                    <a:solidFill>
+                      <a:srgbClr val="FFFFFF"/>
+                    </a:solidFill>
+                  </a:tcPr>
+                </a:tc>
+                <a:tc>
+                  <a:txBody>
+                    <a:bodyPr wrap="square"/>
+                    <a:lstStyle/>
+                    <a:p>
+                      <a:pPr algn="ctr"/>
+                      <a:r>
+                        <a:rPr sz="900" b="0">
+                          <a:solidFill>
+                            <a:srgbClr val="3E823C"/>
+                          </a:solidFill>
+                        </a:rPr>
+                        <a:t>✓</a:t>
+                      </a:r>
+                    </a:p>
+                  </a:txBody>
+                  <a:tcPr marL="54864" marR="54864" marT="18288" marB="18288">
+                    <a:solidFill>
+                      <a:srgbClr val="FFFFFF"/>
+                    </a:solidFill>
+                  </a:tcPr>
+                </a:tc>
+              </a:tr>
+              <a:tr h="312419">
+                <a:tc>
+                  <a:txBody>
+                    <a:bodyPr wrap="square"/>
+                    <a:lstStyle/>
+                    <a:p>
+                      <a:pPr algn="l"/>
+                      <a:r>
+                        <a:rPr sz="950" b="0">
+                          <a:solidFill>
+                            <a:srgbClr val="1F3050"/>
+                          </a:solidFill>
+                        </a:rPr>
+                        <a:t>Qwen3.5-4B</a:t>
+                      </a:r>
+                    </a:p>
+                  </a:txBody>
+                  <a:tcPr marL="54864" marR="54864" marT="18288" marB="18288">
+                    <a:solidFill>
+                      <a:srgbClr val="F2F5FA"/>
+                    </a:solidFill>
+                  </a:tcPr>
+                </a:tc>
+                <a:tc>
+                  <a:txBody>
+                    <a:bodyPr wrap="square"/>
+                    <a:lstStyle/>
+                    <a:p>
+                      <a:pPr algn="r"/>
+                      <a:r>
+                        <a:rPr sz="950" b="0">
+                          <a:solidFill>
+                            <a:srgbClr val="555555"/>
+                          </a:solidFill>
+                        </a:rPr>
+                        <a:t>8.0</a:t>
+                      </a:r>
+                    </a:p>
+                  </a:txBody>
+                  <a:tcPr marL="54864" marR="54864" marT="18288" marB="18288">
+                    <a:solidFill>
+                      <a:srgbClr val="F2F5FA"/>
+                    </a:solidFill>
+                  </a:tcPr>
+                </a:tc>
+                <a:tc>
+                  <a:txBody>
+                    <a:bodyPr wrap="square"/>
+                    <a:lstStyle/>
+                    <a:p>
+                      <a:pPr algn="ctr"/>
+                      <a:r>
+                        <a:rPr sz="950" b="0">
+                          <a:solidFill>
+                            <a:srgbClr val="3E823C"/>
+                          </a:solidFill>
+                        </a:rPr>
+                        <a:t>✓</a:t>
+                      </a:r>
+                    </a:p>
+                  </a:txBody>
+                  <a:tcPr marL="54864" marR="54864" marT="18288" marB="18288">
+                    <a:solidFill>
+                      <a:srgbClr val="F2F5FA"/>
+                    </a:solidFill>
+                  </a:tcPr>
+                </a:tc>
+                <a:tc>
+                  <a:txBody>
+                    <a:bodyPr wrap="square"/>
+                    <a:lstStyle/>
+                    <a:p>
+                      <a:pPr algn="ctr"/>
+                      <a:r>
+                        <a:rPr sz="900" b="0">
+                          <a:solidFill>
+                            <a:srgbClr val="3E823C"/>
+                          </a:solidFill>
+                        </a:rPr>
+                        <a:t>✓</a:t>
+                      </a:r>
+                    </a:p>
+                  </a:txBody>
+                  <a:tcPr marL="54864" marR="54864" marT="18288" marB="18288">
+                    <a:solidFill>
+                      <a:srgbClr val="F2F5FA"/>
+                    </a:solidFill>
+                  </a:tcPr>
+                </a:tc>
+              </a:tr>
+              <a:tr h="312419">
+                <a:tc>
+                  <a:txBody>
+                    <a:bodyPr wrap="square"/>
+                    <a:lstStyle/>
+                    <a:p>
+                      <a:pPr algn="l"/>
+                      <a:r>
+                        <a:rPr sz="950" b="0">
+                          <a:solidFill>
+                            <a:srgbClr val="1F3050"/>
+                          </a:solidFill>
+                        </a:rPr>
+                        <a:t>Qwen3.5-9B</a:t>
+                      </a:r>
+                    </a:p>
+                  </a:txBody>
+                  <a:tcPr marL="54864" marR="54864" marT="18288" marB="18288">
+                    <a:solidFill>
+                      <a:srgbClr val="FFFFFF"/>
+                    </a:solidFill>
+                  </a:tcPr>
+                </a:tc>
+                <a:tc>
+                  <a:txBody>
+                    <a:bodyPr wrap="square"/>
+                    <a:lstStyle/>
+                    <a:p>
+                      <a:pPr algn="r"/>
+                      <a:r>
+                        <a:rPr sz="950" b="0">
+                          <a:solidFill>
+                            <a:srgbClr val="555555"/>
+                          </a:solidFill>
+                        </a:rPr>
+                        <a:t>18</a:t>
+                      </a:r>
+                    </a:p>
+                  </a:txBody>
+                  <a:tcPr marL="54864" marR="54864" marT="18288" marB="18288">
+                    <a:solidFill>
+                      <a:srgbClr val="FFFFFF"/>
+                    </a:solidFill>
+                  </a:tcPr>
+                </a:tc>
+                <a:tc>
+                  <a:txBody>
+                    <a:bodyPr wrap="square"/>
+                    <a:lstStyle/>
+                    <a:p>
+                      <a:pPr algn="ctr"/>
+                      <a:r>
+                        <a:rPr sz="950" b="0">
+                          <a:solidFill>
+                            <a:srgbClr val="3E823C"/>
+                          </a:solidFill>
+                        </a:rPr>
+                        <a:t>✓</a:t>
+                      </a:r>
+                    </a:p>
+                  </a:txBody>
+                  <a:tcPr marL="54864" marR="54864" marT="18288" marB="18288">
+                    <a:solidFill>
+                      <a:srgbClr val="FFFFFF"/>
+                    </a:solidFill>
+                  </a:tcPr>
+                </a:tc>
+                <a:tc>
+                  <a:txBody>
+                    <a:bodyPr wrap="square"/>
+                    <a:lstStyle/>
+                    <a:p>
+                      <a:pPr algn="ctr"/>
+                      <a:r>
+                        <a:rPr sz="900" b="0">
+                          <a:solidFill>
+                            <a:srgbClr val="3E823C"/>
+                          </a:solidFill>
+                        </a:rPr>
+                        <a:t>✓</a:t>
+                      </a:r>
+                    </a:p>
+                  </a:txBody>
+                  <a:tcPr marL="54864" marR="54864" marT="18288" marB="18288">
+                    <a:solidFill>
+                      <a:srgbClr val="FFFFFF"/>
+                    </a:solidFill>
+                  </a:tcPr>
+                </a:tc>
+              </a:tr>
+              <a:tr h="312419">
+                <a:tc>
+                  <a:txBody>
+                    <a:bodyPr wrap="square"/>
+                    <a:lstStyle/>
+                    <a:p>
+                      <a:pPr algn="l"/>
+                      <a:r>
+                        <a:rPr sz="950" b="0">
+                          <a:solidFill>
+                            <a:srgbClr val="1F3050"/>
+                          </a:solidFill>
+                        </a:rPr>
+                        <a:t>Qwen3.6-35B</a:t>
+                      </a:r>
+                    </a:p>
+                  </a:txBody>
+                  <a:tcPr marL="54864" marR="54864" marT="18288" marB="18288">
+                    <a:solidFill>
+                      <a:srgbClr val="F2F5FA"/>
+                    </a:solidFill>
+                  </a:tcPr>
+                </a:tc>
+                <a:tc>
+                  <a:txBody>
+                    <a:bodyPr wrap="square"/>
+                    <a:lstStyle/>
+                    <a:p>
+                      <a:pPr algn="r"/>
+                      <a:r>
+                        <a:rPr sz="950" b="0">
+                          <a:solidFill>
+                            <a:srgbClr val="555555"/>
+                          </a:solidFill>
+                        </a:rPr>
+                        <a:t>70</a:t>
+                      </a:r>
+                    </a:p>
+                  </a:txBody>
+                  <a:tcPr marL="54864" marR="54864" marT="18288" marB="18288">
+                    <a:solidFill>
+                      <a:srgbClr val="F2F5FA"/>
+                    </a:solidFill>
+                  </a:tcPr>
+                </a:tc>
+                <a:tc>
+                  <a:txBody>
+                    <a:bodyPr wrap="square"/>
+                    <a:lstStyle/>
+                    <a:p>
+                      <a:pPr algn="ctr"/>
+                      <a:r>
+                        <a:rPr sz="950" b="0">
+                          <a:solidFill>
+                            <a:srgbClr val="3E823C"/>
+                          </a:solidFill>
+                        </a:rPr>
+                        <a:t>✓</a:t>
+                      </a:r>
+                    </a:p>
+                  </a:txBody>
+                  <a:tcPr marL="54864" marR="54864" marT="18288" marB="18288">
+                    <a:solidFill>
+                      <a:srgbClr val="F2F5FA"/>
+                    </a:solidFill>
+                  </a:tcPr>
+                </a:tc>
+                <a:tc>
+                  <a:txBody>
+                    <a:bodyPr wrap="square"/>
+                    <a:lstStyle/>
+                    <a:p>
+                      <a:pPr algn="ctr"/>
+                      <a:r>
+                        <a:rPr sz="900" b="0">
+                          <a:solidFill>
+                            <a:srgbClr val="A03030"/>
+                          </a:solidFill>
+                        </a:rPr>
+                        <a:t>FP8/TP2</a:t>
+                      </a:r>
+                    </a:p>
+                  </a:txBody>
+                  <a:tcPr marL="54864" marR="54864" marT="18288" marB="18288">
+                    <a:solidFill>
+                      <a:srgbClr val="F2F5FA"/>
+                    </a:solidFill>
+                  </a:tcPr>
+                </a:tc>
+              </a:tr>
+              <a:tr h="312424">
+                <a:tc>
+                  <a:txBody>
+                    <a:bodyPr wrap="square"/>
+                    <a:lstStyle/>
+                    <a:p>
+                      <a:pPr algn="l"/>
+                      <a:r>
+                        <a:rPr sz="950" b="0">
+                          <a:solidFill>
+                            <a:srgbClr val="1F3050"/>
+                          </a:solidFill>
+                        </a:rPr>
+                        <a:t>gemma4-31B †</a:t>
+                      </a:r>
+                    </a:p>
+                  </a:txBody>
+                  <a:tcPr marL="54864" marR="54864" marT="18288" marB="18288">
+                    <a:solidFill>
+                      <a:srgbClr val="FFFFFF"/>
+                    </a:solidFill>
+                  </a:tcPr>
+                </a:tc>
+                <a:tc>
+                  <a:txBody>
+                    <a:bodyPr wrap="square"/>
+                    <a:lstStyle/>
+                    <a:p>
+                      <a:pPr algn="r"/>
+                      <a:r>
+                        <a:rPr sz="950" b="0">
+                          <a:solidFill>
+                            <a:srgbClr val="555555"/>
+                          </a:solidFill>
+                        </a:rPr>
+                        <a:t>62</a:t>
+                      </a:r>
+                    </a:p>
+                  </a:txBody>
+                  <a:tcPr marL="54864" marR="54864" marT="18288" marB="18288">
+                    <a:solidFill>
+                      <a:srgbClr val="FFFFFF"/>
+                    </a:solidFill>
+                  </a:tcPr>
+                </a:tc>
+                <a:tc>
+                  <a:txBody>
+                    <a:bodyPr wrap="square"/>
+                    <a:lstStyle/>
+                    <a:p>
+                      <a:pPr algn="ctr"/>
+                      <a:r>
+                        <a:rPr sz="950" b="0">
+                          <a:solidFill>
+                            <a:srgbClr val="3E823C"/>
+                          </a:solidFill>
+                        </a:rPr>
+                        <a:t>✓</a:t>
+                      </a:r>
+                    </a:p>
+                  </a:txBody>
+                  <a:tcPr marL="54864" marR="54864" marT="18288" marB="18288">
+                    <a:solidFill>
+                      <a:srgbClr val="FFFFFF"/>
+                    </a:solidFill>
+                  </a:tcPr>
+                </a:tc>
+                <a:tc>
+                  <a:txBody>
+                    <a:bodyPr wrap="square"/>
+                    <a:lstStyle/>
+                    <a:p>
+                      <a:pPr algn="ctr"/>
+                      <a:r>
+                        <a:rPr sz="900" b="0">
+                          <a:solidFill>
+                            <a:srgbClr val="A03030"/>
+                          </a:solidFill>
+                        </a:rPr>
+                        <a:t>FP8/TP2</a:t>
+                      </a:r>
+                    </a:p>
+                  </a:txBody>
+                  <a:tcPr marL="54864" marR="54864" marT="18288" marB="18288">
+                    <a:solidFill>
+                      <a:srgbClr val="FFFFFF"/>
+                    </a:solidFill>
+                  </a:tcPr>
+                </a:tc>
+              </a:tr>
+            </a:tbl>
+          </a:graphicData>
+        </a:graphic>
+      </p:graphicFrame>
+      <p:sp>
+        <p:nvSpPr>
+          <p:cNvPr id="7" name="TextBox 6"/>
+          <p:cNvSpPr txBox="1"/>
+          <p:nvPr/>
+        </p:nvSpPr>
+        <p:spPr>
+          <a:xfrm>
+            <a:off x="5669280" y="3127248"/>
+            <a:ext cx="6245352" cy="3108960"/>
+          </a:xfrm>
+          <a:prstGeom prst="rect">
+            <a:avLst/>
+          </a:prstGeom>
+          <a:noFill/>
+        </p:spPr>
+        <p:txBody>
+          <a:bodyPr wrap="square">
+            <a:spAutoFit/>
+          </a:bodyPr>
+          <a:lstStyle/>
+          <a:p>
+            <a:r>
+              <a:rPr sz="1300" b="1">
+                <a:solidFill>
+                  <a:srgbClr val="335588"/>
+                </a:solidFill>
+              </a:rPr>
+              <a:t>Decision &amp; constraints</a:t>
+            </a:r>
+          </a:p>
+          <a:p>
+            <a:pPr>
+              <a:spcBef>
+                <a:spcPts val="700"/>
+              </a:spcBef>
+            </a:pPr>
+            <a:r>
+              <a:rPr sz="1050" b="1">
+                <a:solidFill>
+                  <a:srgbClr val="1F3050"/>
+                </a:solidFill>
+              </a:rPr>
+              <a:t>▪ H200-141GB — fewest moving parts.  </a:t>
+            </a:r>
+            <a:r>
+              <a:rPr sz="1050">
+                <a:solidFill>
+                  <a:srgbClr val="555555"/>
+                </a:solidFill>
+              </a:rPr>
+              <a:t>every model in clean BF16 on a single GPU: no tensor-parallel, no FP8. H100-80 only if budget bites (forces FP8/TP=2 on the 31-35B).</a:t>
+            </a:r>
+          </a:p>
+          <a:p>
+            <a:pPr>
+              <a:spcBef>
+                <a:spcPts val="700"/>
+              </a:spcBef>
+            </a:pPr>
+            <a:r>
+              <a:rPr sz="1050" b="1">
+                <a:solidFill>
+                  <a:srgbClr val="1F3050"/>
+                </a:solidFill>
+              </a:rPr>
+              <a:t>▪ Time-share one box.  </a:t>
+            </a:r>
+            <a:r>
+              <a:rPr sz="1050">
+                <a:solidFill>
+                  <a:srgbClr val="555555"/>
+                </a:solidFill>
+              </a:rPr>
+              <a:t>load a model → run its sweep5v2 + PlanBench cells → swap. Vanilla vLLM OpenAI server; ~40-50 GPU-hrs @ ~$3/hr ≈ $120-150 for all five (PlanBench extra, TBD).</a:t>
+            </a:r>
+          </a:p>
+          <a:p>
+            <a:pPr>
+              <a:spcBef>
+                <a:spcPts val="700"/>
+              </a:spcBef>
+            </a:pPr>
+            <a:r>
+              <a:rPr sz="1050" b="1">
+                <a:solidFill>
+                  <a:srgbClr val="1F3050"/>
+                </a:solidFill>
+              </a:rPr>
+              <a:t>▪ Harness change is tiny.  </a:t>
+            </a:r>
+            <a:r>
+              <a:rPr sz="1050">
+                <a:solidFill>
+                  <a:srgbClr val="555555"/>
+                </a:solidFill>
+              </a:rPr>
+              <a:t>VLLMClient is OpenAI-compatible — only base_url + key move to the rented box. Per-model flags: --max-model-len, --gpu-memory-utilization, --served-model-name.</a:t>
+            </a:r>
+          </a:p>
+          <a:p>
+            <a:pPr>
+              <a:spcBef>
+                <a:spcPts val="700"/>
+              </a:spcBef>
+            </a:pPr>
+            <a:r>
+              <a:rPr sz="1050" b="1">
+                <a:solidFill>
+                  <a:srgbClr val="1F3050"/>
+                </a:solidFill>
+              </a:rPr>
+              <a:t>▪ Corpus isolation is load-bearing.  </a:t>
+            </a:r>
+            <a:r>
+              <a:rPr sz="1050">
+                <a:solidFill>
+                  <a:srgbClr val="555555"/>
+                </a:solidFill>
+              </a:rPr>
+              <a:t>each model's trials.jsonl from ONE backend; keep temp/top_p/max_tokens/seed identical to cluster cells. Never split a model across cluster + rental.</a:t>
+            </a:r>
+          </a:p>
+        </p:txBody>
+      </p:sp>
+      <p:sp>
+        <p:nvSpPr>
+          <p:cNvPr id="8" name="TextBox 7"/>
+          <p:cNvSpPr txBox="1"/>
+          <p:nvPr/>
+        </p:nvSpPr>
+        <p:spPr>
+          <a:xfrm>
+            <a:off x="274320" y="6327648"/>
+            <a:ext cx="11612880" cy="457200"/>
+          </a:xfrm>
+          <a:prstGeom prst="rect">
+            <a:avLst/>
+          </a:prstGeom>
+          <a:noFill/>
+        </p:spPr>
+        <p:txBody>
+          <a:bodyPr wrap="square">
+            <a:spAutoFit/>
+          </a:bodyPr>
+          <a:lstStyle/>
+          <a:p>
+            <a:r>
+              <a:rPr sz="850" i="1">
+                <a:solidFill>
+                  <a:srgbClr val="555555"/>
+                </a:solidFill>
+              </a:rPr>
+              <a:t>Cost &amp; GPU-hours are ESTIMATES from the deployment handoff (~40-50 GPU-hrs @ ~$3/hr H200); confirm with a short pilot before the full sweep. † gemma4-31B optional. Open items for the planner: PlanBench trial/problem count · H200 vs H100+FP8 · whether the 0.8-9B cells stay on the free cluster (cheaper) or move to the box (one backend).</a:t>
             </a:r>
           </a:p>
         </p:txBody>

</xml_diff>